<commit_message>
update lab 05 files
</commit_message>
<xml_diff>
--- a/labs/05_Regularization/05_Regularization_slide.pptx
+++ b/labs/05_Regularization/05_Regularization_slide.pptx
@@ -4,6 +4,9 @@
   <p:sldMasterIdLst>
     <p:sldMasterId id="2147483648" r:id="rId1"/>
   </p:sldMasterIdLst>
+  <p:notesMasterIdLst>
+    <p:notesMasterId r:id="rId27"/>
+  </p:notesMasterIdLst>
   <p:sldIdLst>
     <p:sldId id="256" r:id="rId2"/>
     <p:sldId id="257" r:id="rId3"/>
@@ -136,6 +139,1832 @@
 </p:presentation>
 </file>
 
+<file path=ppt/notesMasters/notesMaster1.xml><?xml version="1.0" encoding="utf-8"?>
+<p:notesMaster xmlns:a="http://schemas.openxmlformats.org/drawingml/2006/main" xmlns:r="http://schemas.openxmlformats.org/officeDocument/2006/relationships" xmlns:p="http://schemas.openxmlformats.org/presentationml/2006/main">
+  <p:cSld>
+    <p:bg>
+      <p:bgRef idx="1001">
+        <a:schemeClr val="bg1"/>
+      </p:bgRef>
+    </p:bg>
+    <p:spTree>
+      <p:nvGrpSpPr>
+        <p:cNvPr id="1" name=""/>
+        <p:cNvGrpSpPr/>
+        <p:nvPr/>
+      </p:nvGrpSpPr>
+      <p:grpSpPr>
+        <a:xfrm>
+          <a:off x="0" y="0"/>
+          <a:ext cx="0" cy="0"/>
+          <a:chOff x="0" y="0"/>
+          <a:chExt cx="0" cy="0"/>
+        </a:xfrm>
+      </p:grpSpPr>
+      <p:sp>
+        <p:nvSpPr>
+          <p:cNvPr id="2" name="頁首版面配置區 1"/>
+          <p:cNvSpPr>
+            <a:spLocks noGrp="1"/>
+          </p:cNvSpPr>
+          <p:nvPr>
+            <p:ph type="hdr" sz="quarter"/>
+          </p:nvPr>
+        </p:nvSpPr>
+        <p:spPr>
+          <a:xfrm>
+            <a:off x="0" y="0"/>
+            <a:ext cx="2971800" cy="458788"/>
+          </a:xfrm>
+          <a:prstGeom prst="rect">
+            <a:avLst/>
+          </a:prstGeom>
+        </p:spPr>
+        <p:txBody>
+          <a:bodyPr vert="horz" lIns="91440" tIns="45720" rIns="91440" bIns="45720" rtlCol="0"/>
+          <a:lstStyle>
+            <a:lvl1pPr algn="l">
+              <a:defRPr sz="1200"/>
+            </a:lvl1pPr>
+          </a:lstStyle>
+          <a:p>
+            <a:endParaRPr kumimoji="1" lang="zh-TW" altLang="en-US"/>
+          </a:p>
+        </p:txBody>
+      </p:sp>
+      <p:sp>
+        <p:nvSpPr>
+          <p:cNvPr id="3" name="日期版面配置區 2"/>
+          <p:cNvSpPr>
+            <a:spLocks noGrp="1"/>
+          </p:cNvSpPr>
+          <p:nvPr>
+            <p:ph type="dt" idx="1"/>
+          </p:nvPr>
+        </p:nvSpPr>
+        <p:spPr>
+          <a:xfrm>
+            <a:off x="3884613" y="0"/>
+            <a:ext cx="2971800" cy="458788"/>
+          </a:xfrm>
+          <a:prstGeom prst="rect">
+            <a:avLst/>
+          </a:prstGeom>
+        </p:spPr>
+        <p:txBody>
+          <a:bodyPr vert="horz" lIns="91440" tIns="45720" rIns="91440" bIns="45720" rtlCol="0"/>
+          <a:lstStyle>
+            <a:lvl1pPr algn="r">
+              <a:defRPr sz="1200"/>
+            </a:lvl1pPr>
+          </a:lstStyle>
+          <a:p>
+            <a:fld id="{7B1FDEB0-85FF-BA46-8B1B-2B29ACAD46B5}" type="datetimeFigureOut">
+              <a:rPr kumimoji="1" lang="zh-TW" altLang="en-US" smtClean="0"/>
+              <a:t>2026/9/24</a:t>
+            </a:fld>
+            <a:endParaRPr kumimoji="1" lang="zh-TW" altLang="en-US"/>
+          </a:p>
+        </p:txBody>
+      </p:sp>
+      <p:sp>
+        <p:nvSpPr>
+          <p:cNvPr id="4" name="投影片影像版面配置區 3"/>
+          <p:cNvSpPr>
+            <a:spLocks noGrp="1" noRot="1" noChangeAspect="1"/>
+          </p:cNvSpPr>
+          <p:nvPr>
+            <p:ph type="sldImg" idx="2"/>
+          </p:nvPr>
+        </p:nvSpPr>
+        <p:spPr>
+          <a:xfrm>
+            <a:off x="685800" y="1143000"/>
+            <a:ext cx="5486400" cy="3086100"/>
+          </a:xfrm>
+          <a:prstGeom prst="rect">
+            <a:avLst/>
+          </a:prstGeom>
+          <a:noFill/>
+          <a:ln w="12700">
+            <a:solidFill>
+              <a:prstClr val="black"/>
+            </a:solidFill>
+          </a:ln>
+        </p:spPr>
+        <p:txBody>
+          <a:bodyPr vert="horz" lIns="91440" tIns="45720" rIns="91440" bIns="45720" rtlCol="0" anchor="ctr"/>
+          <a:lstStyle/>
+          <a:p>
+            <a:endParaRPr lang="zh-TW" altLang="en-US"/>
+          </a:p>
+        </p:txBody>
+      </p:sp>
+      <p:sp>
+        <p:nvSpPr>
+          <p:cNvPr id="5" name="備忘稿版面配置區 4"/>
+          <p:cNvSpPr>
+            <a:spLocks noGrp="1"/>
+          </p:cNvSpPr>
+          <p:nvPr>
+            <p:ph type="body" sz="quarter" idx="3"/>
+          </p:nvPr>
+        </p:nvSpPr>
+        <p:spPr>
+          <a:xfrm>
+            <a:off x="685800" y="4400550"/>
+            <a:ext cx="5486400" cy="3600450"/>
+          </a:xfrm>
+          <a:prstGeom prst="rect">
+            <a:avLst/>
+          </a:prstGeom>
+        </p:spPr>
+        <p:txBody>
+          <a:bodyPr vert="horz" lIns="91440" tIns="45720" rIns="91440" bIns="45720" rtlCol="0"/>
+          <a:lstStyle/>
+          <a:p>
+            <a:pPr lvl="0"/>
+            <a:r>
+              <a:rPr kumimoji="1" lang="zh-TW" altLang="en-US"/>
+              <a:t>按一下以編輯母片文字樣式</a:t>
+            </a:r>
+          </a:p>
+          <a:p>
+            <a:pPr lvl="1"/>
+            <a:r>
+              <a:rPr kumimoji="1" lang="zh-TW" altLang="en-US"/>
+              <a:t>第二層</a:t>
+            </a:r>
+          </a:p>
+          <a:p>
+            <a:pPr lvl="2"/>
+            <a:r>
+              <a:rPr kumimoji="1" lang="zh-TW" altLang="en-US"/>
+              <a:t>第三層</a:t>
+            </a:r>
+          </a:p>
+          <a:p>
+            <a:pPr lvl="3"/>
+            <a:r>
+              <a:rPr kumimoji="1" lang="zh-TW" altLang="en-US"/>
+              <a:t>第四層</a:t>
+            </a:r>
+          </a:p>
+          <a:p>
+            <a:pPr lvl="4"/>
+            <a:r>
+              <a:rPr kumimoji="1" lang="zh-TW" altLang="en-US"/>
+              <a:t>第五層</a:t>
+            </a:r>
+          </a:p>
+        </p:txBody>
+      </p:sp>
+      <p:sp>
+        <p:nvSpPr>
+          <p:cNvPr id="6" name="頁尾版面配置區 5"/>
+          <p:cNvSpPr>
+            <a:spLocks noGrp="1"/>
+          </p:cNvSpPr>
+          <p:nvPr>
+            <p:ph type="ftr" sz="quarter" idx="4"/>
+          </p:nvPr>
+        </p:nvSpPr>
+        <p:spPr>
+          <a:xfrm>
+            <a:off x="0" y="8685213"/>
+            <a:ext cx="2971800" cy="458787"/>
+          </a:xfrm>
+          <a:prstGeom prst="rect">
+            <a:avLst/>
+          </a:prstGeom>
+        </p:spPr>
+        <p:txBody>
+          <a:bodyPr vert="horz" lIns="91440" tIns="45720" rIns="91440" bIns="45720" rtlCol="0" anchor="b"/>
+          <a:lstStyle>
+            <a:lvl1pPr algn="l">
+              <a:defRPr sz="1200"/>
+            </a:lvl1pPr>
+          </a:lstStyle>
+          <a:p>
+            <a:endParaRPr kumimoji="1" lang="zh-TW" altLang="en-US"/>
+          </a:p>
+        </p:txBody>
+      </p:sp>
+      <p:sp>
+        <p:nvSpPr>
+          <p:cNvPr id="7" name="投影片編號版面配置區 6"/>
+          <p:cNvSpPr>
+            <a:spLocks noGrp="1"/>
+          </p:cNvSpPr>
+          <p:nvPr>
+            <p:ph type="sldNum" sz="quarter" idx="5"/>
+          </p:nvPr>
+        </p:nvSpPr>
+        <p:spPr>
+          <a:xfrm>
+            <a:off x="3884613" y="8685213"/>
+            <a:ext cx="2971800" cy="458787"/>
+          </a:xfrm>
+          <a:prstGeom prst="rect">
+            <a:avLst/>
+          </a:prstGeom>
+        </p:spPr>
+        <p:txBody>
+          <a:bodyPr vert="horz" lIns="91440" tIns="45720" rIns="91440" bIns="45720" rtlCol="0" anchor="b"/>
+          <a:lstStyle>
+            <a:lvl1pPr algn="r">
+              <a:defRPr sz="1200"/>
+            </a:lvl1pPr>
+          </a:lstStyle>
+          <a:p>
+            <a:fld id="{5C1B2D8A-08BB-564F-B065-2252CD015E6C}" type="slidenum">
+              <a:rPr kumimoji="1" lang="zh-TW" altLang="en-US" smtClean="0"/>
+              <a:t>‹#›</a:t>
+            </a:fld>
+            <a:endParaRPr kumimoji="1" lang="zh-TW" altLang="en-US"/>
+          </a:p>
+        </p:txBody>
+      </p:sp>
+    </p:spTree>
+    <p:extLst>
+      <p:ext uri="{BB962C8B-B14F-4D97-AF65-F5344CB8AC3E}">
+        <p14:creationId xmlns:p14="http://schemas.microsoft.com/office/powerpoint/2010/main" val="3749956868"/>
+      </p:ext>
+    </p:extLst>
+  </p:cSld>
+  <p:clrMap bg1="lt1" tx1="dk1" bg2="lt2" tx2="dk2" accent1="accent1" accent2="accent2" accent3="accent3" accent4="accent4" accent5="accent5" accent6="accent6" hlink="hlink" folHlink="folHlink"/>
+  <p:notesStyle>
+    <a:lvl1pPr marL="0" algn="l" defTabSz="914400" rtl="0" eaLnBrk="1" latinLnBrk="0" hangingPunct="1">
+      <a:defRPr sz="1200" kern="1200">
+        <a:solidFill>
+          <a:schemeClr val="tx1"/>
+        </a:solidFill>
+        <a:latin typeface="+mn-lt"/>
+        <a:ea typeface="+mn-ea"/>
+        <a:cs typeface="+mn-cs"/>
+      </a:defRPr>
+    </a:lvl1pPr>
+    <a:lvl2pPr marL="457200" algn="l" defTabSz="914400" rtl="0" eaLnBrk="1" latinLnBrk="0" hangingPunct="1">
+      <a:defRPr sz="1200" kern="1200">
+        <a:solidFill>
+          <a:schemeClr val="tx1"/>
+        </a:solidFill>
+        <a:latin typeface="+mn-lt"/>
+        <a:ea typeface="+mn-ea"/>
+        <a:cs typeface="+mn-cs"/>
+      </a:defRPr>
+    </a:lvl2pPr>
+    <a:lvl3pPr marL="914400" algn="l" defTabSz="914400" rtl="0" eaLnBrk="1" latinLnBrk="0" hangingPunct="1">
+      <a:defRPr sz="1200" kern="1200">
+        <a:solidFill>
+          <a:schemeClr val="tx1"/>
+        </a:solidFill>
+        <a:latin typeface="+mn-lt"/>
+        <a:ea typeface="+mn-ea"/>
+        <a:cs typeface="+mn-cs"/>
+      </a:defRPr>
+    </a:lvl3pPr>
+    <a:lvl4pPr marL="1371600" algn="l" defTabSz="914400" rtl="0" eaLnBrk="1" latinLnBrk="0" hangingPunct="1">
+      <a:defRPr sz="1200" kern="1200">
+        <a:solidFill>
+          <a:schemeClr val="tx1"/>
+        </a:solidFill>
+        <a:latin typeface="+mn-lt"/>
+        <a:ea typeface="+mn-ea"/>
+        <a:cs typeface="+mn-cs"/>
+      </a:defRPr>
+    </a:lvl4pPr>
+    <a:lvl5pPr marL="1828800" algn="l" defTabSz="914400" rtl="0" eaLnBrk="1" latinLnBrk="0" hangingPunct="1">
+      <a:defRPr sz="1200" kern="1200">
+        <a:solidFill>
+          <a:schemeClr val="tx1"/>
+        </a:solidFill>
+        <a:latin typeface="+mn-lt"/>
+        <a:ea typeface="+mn-ea"/>
+        <a:cs typeface="+mn-cs"/>
+      </a:defRPr>
+    </a:lvl5pPr>
+    <a:lvl6pPr marL="2286000" algn="l" defTabSz="914400" rtl="0" eaLnBrk="1" latinLnBrk="0" hangingPunct="1">
+      <a:defRPr sz="1200" kern="1200">
+        <a:solidFill>
+          <a:schemeClr val="tx1"/>
+        </a:solidFill>
+        <a:latin typeface="+mn-lt"/>
+        <a:ea typeface="+mn-ea"/>
+        <a:cs typeface="+mn-cs"/>
+      </a:defRPr>
+    </a:lvl6pPr>
+    <a:lvl7pPr marL="2743200" algn="l" defTabSz="914400" rtl="0" eaLnBrk="1" latinLnBrk="0" hangingPunct="1">
+      <a:defRPr sz="1200" kern="1200">
+        <a:solidFill>
+          <a:schemeClr val="tx1"/>
+        </a:solidFill>
+        <a:latin typeface="+mn-lt"/>
+        <a:ea typeface="+mn-ea"/>
+        <a:cs typeface="+mn-cs"/>
+      </a:defRPr>
+    </a:lvl7pPr>
+    <a:lvl8pPr marL="3200400" algn="l" defTabSz="914400" rtl="0" eaLnBrk="1" latinLnBrk="0" hangingPunct="1">
+      <a:defRPr sz="1200" kern="1200">
+        <a:solidFill>
+          <a:schemeClr val="tx1"/>
+        </a:solidFill>
+        <a:latin typeface="+mn-lt"/>
+        <a:ea typeface="+mn-ea"/>
+        <a:cs typeface="+mn-cs"/>
+      </a:defRPr>
+    </a:lvl8pPr>
+    <a:lvl9pPr marL="3657600" algn="l" defTabSz="914400" rtl="0" eaLnBrk="1" latinLnBrk="0" hangingPunct="1">
+      <a:defRPr sz="1200" kern="1200">
+        <a:solidFill>
+          <a:schemeClr val="tx1"/>
+        </a:solidFill>
+        <a:latin typeface="+mn-lt"/>
+        <a:ea typeface="+mn-ea"/>
+        <a:cs typeface="+mn-cs"/>
+      </a:defRPr>
+    </a:lvl9pPr>
+  </p:notesStyle>
+</p:notesMaster>
+</file>
+
+<file path=ppt/notesSlides/notesSlide1.xml><?xml version="1.0" encoding="utf-8"?>
+<p:notes xmlns:a="http://schemas.openxmlformats.org/drawingml/2006/main" xmlns:r="http://schemas.openxmlformats.org/officeDocument/2006/relationships" xmlns:p="http://schemas.openxmlformats.org/presentationml/2006/main">
+  <p:cSld>
+    <p:spTree>
+      <p:nvGrpSpPr>
+        <p:cNvPr id="1" name=""/>
+        <p:cNvGrpSpPr/>
+        <p:nvPr/>
+      </p:nvGrpSpPr>
+      <p:grpSpPr>
+        <a:xfrm>
+          <a:off x="0" y="0"/>
+          <a:ext cx="0" cy="0"/>
+          <a:chOff x="0" y="0"/>
+          <a:chExt cx="0" cy="0"/>
+        </a:xfrm>
+      </p:grpSpPr>
+      <p:sp>
+        <p:nvSpPr>
+          <p:cNvPr id="2" name="投影片影像版面配置區 1"/>
+          <p:cNvSpPr>
+            <a:spLocks noGrp="1" noRot="1" noChangeAspect="1"/>
+          </p:cNvSpPr>
+          <p:nvPr>
+            <p:ph type="sldImg"/>
+          </p:nvPr>
+        </p:nvSpPr>
+        <p:spPr/>
+      </p:sp>
+      <p:sp>
+        <p:nvSpPr>
+          <p:cNvPr id="3" name="備忘稿版面配置區 2"/>
+          <p:cNvSpPr>
+            <a:spLocks noGrp="1"/>
+          </p:cNvSpPr>
+          <p:nvPr>
+            <p:ph type="body" idx="1"/>
+          </p:nvPr>
+        </p:nvSpPr>
+        <p:spPr/>
+        <p:txBody>
+          <a:bodyPr/>
+          <a:lstStyle/>
+          <a:p>
+            <a:r>
+              <a:rPr lang="zh-TW" altLang="zh-TW" dirty="0"/>
+              <a:t>模型在訓練資料上表現好，不代表在沒看過的資料上也會好。我們要怎麼讓它在新資料上也表現好？</a:t>
+            </a:r>
+            <a:endParaRPr lang="en-US" altLang="zh-TW" dirty="0"/>
+          </a:p>
+          <a:p>
+            <a:r>
+              <a:rPr kumimoji="1" lang="zh-TW" altLang="en-US" dirty="0"/>
+              <a:t>要怎麼提升模型的泛化能力</a:t>
+            </a:r>
+          </a:p>
+        </p:txBody>
+      </p:sp>
+      <p:sp>
+        <p:nvSpPr>
+          <p:cNvPr id="4" name="投影片編號版面配置區 3"/>
+          <p:cNvSpPr>
+            <a:spLocks noGrp="1"/>
+          </p:cNvSpPr>
+          <p:nvPr>
+            <p:ph type="sldNum" sz="quarter" idx="5"/>
+          </p:nvPr>
+        </p:nvSpPr>
+        <p:spPr/>
+        <p:txBody>
+          <a:bodyPr/>
+          <a:lstStyle/>
+          <a:p>
+            <a:fld id="{5C1B2D8A-08BB-564F-B065-2252CD015E6C}" type="slidenum">
+              <a:rPr kumimoji="1" lang="zh-TW" altLang="en-US" smtClean="0"/>
+              <a:t>2</a:t>
+            </a:fld>
+            <a:endParaRPr kumimoji="1" lang="zh-TW" altLang="en-US"/>
+          </a:p>
+        </p:txBody>
+      </p:sp>
+    </p:spTree>
+    <p:extLst>
+      <p:ext uri="{BB962C8B-B14F-4D97-AF65-F5344CB8AC3E}">
+        <p14:creationId xmlns:p14="http://schemas.microsoft.com/office/powerpoint/2010/main" val="126057676"/>
+      </p:ext>
+    </p:extLst>
+  </p:cSld>
+  <p:clrMapOvr>
+    <a:masterClrMapping/>
+  </p:clrMapOvr>
+</p:notes>
+</file>
+
+<file path=ppt/notesSlides/notesSlide10.xml><?xml version="1.0" encoding="utf-8"?>
+<p:notes xmlns:a="http://schemas.openxmlformats.org/drawingml/2006/main" xmlns:r="http://schemas.openxmlformats.org/officeDocument/2006/relationships" xmlns:p="http://schemas.openxmlformats.org/presentationml/2006/main">
+  <p:cSld>
+    <p:spTree>
+      <p:nvGrpSpPr>
+        <p:cNvPr id="1" name=""/>
+        <p:cNvGrpSpPr/>
+        <p:nvPr/>
+      </p:nvGrpSpPr>
+      <p:grpSpPr>
+        <a:xfrm>
+          <a:off x="0" y="0"/>
+          <a:ext cx="0" cy="0"/>
+          <a:chOff x="0" y="0"/>
+          <a:chExt cx="0" cy="0"/>
+        </a:xfrm>
+      </p:grpSpPr>
+      <p:sp>
+        <p:nvSpPr>
+          <p:cNvPr id="2" name="投影片影像版面配置區 1"/>
+          <p:cNvSpPr>
+            <a:spLocks noGrp="1" noRot="1" noChangeAspect="1"/>
+          </p:cNvSpPr>
+          <p:nvPr>
+            <p:ph type="sldImg"/>
+          </p:nvPr>
+        </p:nvSpPr>
+        <p:spPr/>
+      </p:sp>
+      <p:sp>
+        <p:nvSpPr>
+          <p:cNvPr id="3" name="備忘稿版面配置區 2"/>
+          <p:cNvSpPr>
+            <a:spLocks noGrp="1"/>
+          </p:cNvSpPr>
+          <p:nvPr>
+            <p:ph type="body" idx="1"/>
+          </p:nvPr>
+        </p:nvSpPr>
+        <p:spPr/>
+        <p:txBody>
+          <a:bodyPr/>
+          <a:lstStyle/>
+          <a:p>
+            <a:r>
+              <a:rPr lang="zh-TW" altLang="zh-TW" dirty="0"/>
+              <a:t>第二種 weight decay 是 LASSO。公式跟 Ridge 幾乎一樣，只是懲罰項從 w 的平方和，換成 w 的絕對值和。</a:t>
+            </a:r>
+            <a:endParaRPr lang="en-US" altLang="zh-TW" dirty="0"/>
+          </a:p>
+          <a:p>
+            <a:pPr rtl="0"/>
+            <a:r>
+              <a:rPr lang="zh-TW" altLang="zh-TW" b="1" dirty="0"/>
+              <a:t>α = 0</a:t>
+            </a:r>
+            <a:r>
+              <a:rPr lang="zh-TW" altLang="zh-TW" dirty="0"/>
+              <a:t>，沒有懲罰，test MSE 是 61，還是 overfit。</a:t>
+            </a:r>
+          </a:p>
+          <a:p>
+            <a:pPr rtl="0"/>
+            <a:r>
+              <a:rPr lang="zh-TW" altLang="zh-TW" dirty="0"/>
+              <a:t>α 慢慢加大，0.001、0.01，test MSE 一路下降，在 </a:t>
+            </a:r>
+            <a:r>
+              <a:rPr lang="zh-TW" altLang="zh-TW" b="1" dirty="0"/>
+              <a:t>α = 0.1</a:t>
+            </a:r>
+            <a:r>
+              <a:rPr lang="zh-TW" altLang="zh-TW" dirty="0"/>
+              <a:t> 時最低，是 </a:t>
+            </a:r>
+            <a:r>
+              <a:rPr lang="zh-TW" altLang="zh-TW" b="1" dirty="0"/>
+              <a:t>15.52</a:t>
+            </a:r>
+            <a:r>
+              <a:rPr lang="zh-TW" altLang="zh-TW" dirty="0"/>
+              <a:t>，跟 Ridge 最好的 15.16 差不多。</a:t>
+            </a:r>
+          </a:p>
+          <a:p>
+            <a:pPr rtl="0"/>
+            <a:r>
+              <a:rPr lang="zh-TW" altLang="zh-TW" dirty="0"/>
+              <a:t>再加大到 </a:t>
+            </a:r>
+            <a:r>
+              <a:rPr lang="zh-TW" altLang="zh-TW" b="1" dirty="0"/>
+              <a:t>α = 1</a:t>
+            </a:r>
+            <a:r>
+              <a:rPr lang="zh-TW" altLang="zh-TW" dirty="0"/>
+              <a:t>，test MSE 回升到 22，training MSE 也升到 14，開始 underfit。</a:t>
+            </a:r>
+          </a:p>
+          <a:p>
+            <a:pPr rtl="0"/>
+            <a:r>
+              <a:rPr lang="zh-TW" altLang="zh-TW" dirty="0"/>
+              <a:t>到 </a:t>
+            </a:r>
+            <a:r>
+              <a:rPr lang="zh-TW" altLang="zh-TW" b="1" dirty="0"/>
+              <a:t>α = 10</a:t>
+            </a:r>
+            <a:r>
+              <a:rPr lang="zh-TW" altLang="zh-TW" dirty="0"/>
+              <a:t>，training MSE 55、testing MSE 53，兩個都很高，而且幾乎一樣。這就是 p.8 講的 underfit 特徵：兩條線都很高、靠在一起。</a:t>
+            </a:r>
+          </a:p>
+          <a:p>
+            <a:endParaRPr kumimoji="1" lang="zh-TW" altLang="en-US" dirty="0"/>
+          </a:p>
+        </p:txBody>
+      </p:sp>
+      <p:sp>
+        <p:nvSpPr>
+          <p:cNvPr id="4" name="投影片編號版面配置區 3"/>
+          <p:cNvSpPr>
+            <a:spLocks noGrp="1"/>
+          </p:cNvSpPr>
+          <p:nvPr>
+            <p:ph type="sldNum" sz="quarter" idx="5"/>
+          </p:nvPr>
+        </p:nvSpPr>
+        <p:spPr/>
+        <p:txBody>
+          <a:bodyPr/>
+          <a:lstStyle/>
+          <a:p>
+            <a:fld id="{5C1B2D8A-08BB-564F-B065-2252CD015E6C}" type="slidenum">
+              <a:rPr kumimoji="1" lang="zh-TW" altLang="en-US" smtClean="0"/>
+              <a:t>15</a:t>
+            </a:fld>
+            <a:endParaRPr kumimoji="1" lang="zh-TW" altLang="en-US"/>
+          </a:p>
+        </p:txBody>
+      </p:sp>
+    </p:spTree>
+    <p:extLst>
+      <p:ext uri="{BB962C8B-B14F-4D97-AF65-F5344CB8AC3E}">
+        <p14:creationId xmlns:p14="http://schemas.microsoft.com/office/powerpoint/2010/main" val="3535383544"/>
+      </p:ext>
+    </p:extLst>
+  </p:cSld>
+  <p:clrMapOvr>
+    <a:masterClrMapping/>
+  </p:clrMapOvr>
+</p:notes>
+</file>
+
+<file path=ppt/notesSlides/notesSlide11.xml><?xml version="1.0" encoding="utf-8"?>
+<p:notes xmlns:a="http://schemas.openxmlformats.org/drawingml/2006/main" xmlns:r="http://schemas.openxmlformats.org/officeDocument/2006/relationships" xmlns:p="http://schemas.openxmlformats.org/presentationml/2006/main">
+  <p:cSld>
+    <p:spTree>
+      <p:nvGrpSpPr>
+        <p:cNvPr id="1" name=""/>
+        <p:cNvGrpSpPr/>
+        <p:nvPr/>
+      </p:nvGrpSpPr>
+      <p:grpSpPr>
+        <a:xfrm>
+          <a:off x="0" y="0"/>
+          <a:ext cx="0" cy="0"/>
+          <a:chOff x="0" y="0"/>
+          <a:chExt cx="0" cy="0"/>
+        </a:xfrm>
+      </p:grpSpPr>
+      <p:sp>
+        <p:nvSpPr>
+          <p:cNvPr id="2" name="投影片影像版面配置區 1"/>
+          <p:cNvSpPr>
+            <a:spLocks noGrp="1" noRot="1" noChangeAspect="1"/>
+          </p:cNvSpPr>
+          <p:nvPr>
+            <p:ph type="sldImg"/>
+          </p:nvPr>
+        </p:nvSpPr>
+        <p:spPr/>
+      </p:sp>
+      <p:sp>
+        <p:nvSpPr>
+          <p:cNvPr id="3" name="備忘稿版面配置區 2"/>
+          <p:cNvSpPr>
+            <a:spLocks noGrp="1"/>
+          </p:cNvSpPr>
+          <p:nvPr>
+            <p:ph type="body" idx="1"/>
+          </p:nvPr>
+        </p:nvSpPr>
+        <p:spPr/>
+        <p:txBody>
+          <a:bodyPr/>
+          <a:lstStyle/>
+          <a:p>
+            <a:r>
+              <a:rPr kumimoji="1" lang="zh-TW" altLang="en-US" dirty="0"/>
+              <a:t>前面有看到 </a:t>
+            </a:r>
+            <a:r>
+              <a:rPr kumimoji="1" lang="en-US" altLang="zh-TW" dirty="0"/>
+              <a:t>ridge regression </a:t>
+            </a:r>
+            <a:r>
+              <a:rPr kumimoji="1" lang="zh-TW" altLang="en-US" dirty="0"/>
+              <a:t>和 </a:t>
+            </a:r>
+            <a:r>
+              <a:rPr kumimoji="1" lang="en-US" altLang="zh-TW" dirty="0"/>
+              <a:t>lasso</a:t>
+            </a:r>
+            <a:r>
+              <a:rPr kumimoji="1" lang="zh-TW" altLang="en-US" dirty="0"/>
+              <a:t> 跑了不同的 </a:t>
+            </a:r>
+            <a:r>
+              <a:rPr kumimoji="1" lang="en-US" altLang="zh-TW" dirty="0"/>
+              <a:t>alpha</a:t>
+            </a:r>
+            <a:r>
+              <a:rPr kumimoji="1" lang="zh-TW" altLang="en-US" dirty="0"/>
+              <a:t>，這個選的好不好會決定模型會不會 </a:t>
+            </a:r>
+            <a:r>
+              <a:rPr kumimoji="1" lang="en-US" altLang="zh-TW" dirty="0"/>
+              <a:t>underfit </a:t>
+            </a:r>
+            <a:r>
+              <a:rPr kumimoji="1" lang="zh-TW" altLang="en-US" dirty="0"/>
+              <a:t>或 </a:t>
+            </a:r>
+            <a:r>
+              <a:rPr kumimoji="1" lang="en-US" altLang="zh-TW" dirty="0"/>
+              <a:t>overfit</a:t>
+            </a:r>
+          </a:p>
+          <a:p>
+            <a:r>
+              <a:rPr kumimoji="1" lang="zh-TW" altLang="en-US" dirty="0"/>
+              <a:t>為什麼不能用 </a:t>
+            </a:r>
+            <a:r>
+              <a:rPr kumimoji="1" lang="en-US" altLang="zh-TW" dirty="0"/>
+              <a:t>test set </a:t>
+            </a:r>
+            <a:r>
+              <a:rPr kumimoji="1" lang="zh-TW" altLang="en-US" dirty="0"/>
+              <a:t>選？</a:t>
+            </a:r>
+            <a:endParaRPr kumimoji="1" lang="en-US" altLang="zh-TW" dirty="0"/>
+          </a:p>
+          <a:p>
+            <a:r>
+              <a:rPr lang="zh-TW" altLang="zh-TW" dirty="0"/>
+              <a:t>Test set 的用途，是模擬模型遇到『從沒看過的資料』時的表現。如果用它來挑 α，等於讓 test set 參與了決定，它就不再是『沒看過的資料』了。這樣回報出來的 test error 會太樂觀，模型真正上線時，表現可能沒這麼好。</a:t>
+            </a:r>
+            <a:endParaRPr lang="en-US" altLang="zh-TW" dirty="0"/>
+          </a:p>
+          <a:p>
+            <a:r>
+              <a:rPr kumimoji="1" lang="zh-TW" altLang="en-US" dirty="0"/>
+              <a:t>比較好的方法是在 </a:t>
+            </a:r>
+            <a:r>
+              <a:rPr kumimoji="1" lang="en-US" altLang="zh-TW" dirty="0"/>
+              <a:t>training data </a:t>
+            </a:r>
+            <a:r>
+              <a:rPr kumimoji="1" lang="zh-TW" altLang="en-US" dirty="0"/>
+              <a:t>中切分出一塊是 </a:t>
+            </a:r>
+            <a:r>
+              <a:rPr kumimoji="1" lang="en-US" altLang="zh-TW" dirty="0"/>
+              <a:t>validation data</a:t>
+            </a:r>
+            <a:r>
+              <a:rPr kumimoji="1" lang="zh-TW" altLang="en-US" dirty="0"/>
+              <a:t>，拿來挑 </a:t>
+            </a:r>
+            <a:r>
+              <a:rPr kumimoji="1" lang="en-US" altLang="zh-TW" dirty="0"/>
+              <a:t>hyperparameter </a:t>
+            </a:r>
+            <a:r>
+              <a:rPr kumimoji="1" lang="zh-TW" altLang="en-US" dirty="0"/>
+              <a:t>用的</a:t>
+            </a:r>
+            <a:endParaRPr kumimoji="1" lang="en-US" altLang="zh-TW" dirty="0"/>
+          </a:p>
+        </p:txBody>
+      </p:sp>
+      <p:sp>
+        <p:nvSpPr>
+          <p:cNvPr id="4" name="投影片編號版面配置區 3"/>
+          <p:cNvSpPr>
+            <a:spLocks noGrp="1"/>
+          </p:cNvSpPr>
+          <p:nvPr>
+            <p:ph type="sldNum" sz="quarter" idx="5"/>
+          </p:nvPr>
+        </p:nvSpPr>
+        <p:spPr/>
+        <p:txBody>
+          <a:bodyPr/>
+          <a:lstStyle/>
+          <a:p>
+            <a:fld id="{5C1B2D8A-08BB-564F-B065-2252CD015E6C}" type="slidenum">
+              <a:rPr kumimoji="1" lang="zh-TW" altLang="en-US" smtClean="0"/>
+              <a:t>20</a:t>
+            </a:fld>
+            <a:endParaRPr kumimoji="1" lang="zh-TW" altLang="en-US"/>
+          </a:p>
+        </p:txBody>
+      </p:sp>
+    </p:spTree>
+    <p:extLst>
+      <p:ext uri="{BB962C8B-B14F-4D97-AF65-F5344CB8AC3E}">
+        <p14:creationId xmlns:p14="http://schemas.microsoft.com/office/powerpoint/2010/main" val="3467444591"/>
+      </p:ext>
+    </p:extLst>
+  </p:cSld>
+  <p:clrMapOvr>
+    <a:masterClrMapping/>
+  </p:clrMapOvr>
+</p:notes>
+</file>
+
+<file path=ppt/notesSlides/notesSlide2.xml><?xml version="1.0" encoding="utf-8"?>
+<p:notes xmlns:a="http://schemas.openxmlformats.org/drawingml/2006/main" xmlns:r="http://schemas.openxmlformats.org/officeDocument/2006/relationships" xmlns:p="http://schemas.openxmlformats.org/presentationml/2006/main">
+  <p:cSld>
+    <p:spTree>
+      <p:nvGrpSpPr>
+        <p:cNvPr id="1" name=""/>
+        <p:cNvGrpSpPr/>
+        <p:nvPr/>
+      </p:nvGrpSpPr>
+      <p:grpSpPr>
+        <a:xfrm>
+          <a:off x="0" y="0"/>
+          <a:ext cx="0" cy="0"/>
+          <a:chOff x="0" y="0"/>
+          <a:chExt cx="0" cy="0"/>
+        </a:xfrm>
+      </p:grpSpPr>
+      <p:sp>
+        <p:nvSpPr>
+          <p:cNvPr id="2" name="投影片影像版面配置區 1"/>
+          <p:cNvSpPr>
+            <a:spLocks noGrp="1" noRot="1" noChangeAspect="1"/>
+          </p:cNvSpPr>
+          <p:nvPr>
+            <p:ph type="sldImg"/>
+          </p:nvPr>
+        </p:nvSpPr>
+        <p:spPr/>
+      </p:sp>
+      <p:sp>
+        <p:nvSpPr>
+          <p:cNvPr id="3" name="備忘稿版面配置區 2"/>
+          <p:cNvSpPr>
+            <a:spLocks noGrp="1"/>
+          </p:cNvSpPr>
+          <p:nvPr>
+            <p:ph type="body" idx="1"/>
+          </p:nvPr>
+        </p:nvSpPr>
+        <p:spPr/>
+        <p:txBody>
+          <a:bodyPr/>
+          <a:lstStyle/>
+          <a:p>
+            <a:r>
+              <a:rPr kumimoji="1" lang="en-US" altLang="zh-TW" dirty="0"/>
+              <a:t>Learning theory </a:t>
+            </a:r>
+            <a:r>
+              <a:rPr kumimoji="1" lang="zh-TW" altLang="en-US" dirty="0"/>
+              <a:t>主要在說模型在新資料上表現得好不好，主要受到模型複雜度和資料量的影響</a:t>
+            </a:r>
+          </a:p>
+        </p:txBody>
+      </p:sp>
+      <p:sp>
+        <p:nvSpPr>
+          <p:cNvPr id="4" name="投影片編號版面配置區 3"/>
+          <p:cNvSpPr>
+            <a:spLocks noGrp="1"/>
+          </p:cNvSpPr>
+          <p:nvPr>
+            <p:ph type="sldNum" sz="quarter" idx="5"/>
+          </p:nvPr>
+        </p:nvSpPr>
+        <p:spPr/>
+        <p:txBody>
+          <a:bodyPr/>
+          <a:lstStyle/>
+          <a:p>
+            <a:fld id="{5C1B2D8A-08BB-564F-B065-2252CD015E6C}" type="slidenum">
+              <a:rPr kumimoji="1" lang="zh-TW" altLang="en-US" smtClean="0"/>
+              <a:t>6</a:t>
+            </a:fld>
+            <a:endParaRPr kumimoji="1" lang="zh-TW" altLang="en-US"/>
+          </a:p>
+        </p:txBody>
+      </p:sp>
+    </p:spTree>
+    <p:extLst>
+      <p:ext uri="{BB962C8B-B14F-4D97-AF65-F5344CB8AC3E}">
+        <p14:creationId xmlns:p14="http://schemas.microsoft.com/office/powerpoint/2010/main" val="2215007982"/>
+      </p:ext>
+    </p:extLst>
+  </p:cSld>
+  <p:clrMapOvr>
+    <a:masterClrMapping/>
+  </p:clrMapOvr>
+</p:notes>
+</file>
+
+<file path=ppt/notesSlides/notesSlide3.xml><?xml version="1.0" encoding="utf-8"?>
+<p:notes xmlns:a="http://schemas.openxmlformats.org/drawingml/2006/main" xmlns:r="http://schemas.openxmlformats.org/officeDocument/2006/relationships" xmlns:p="http://schemas.openxmlformats.org/presentationml/2006/main">
+  <p:cSld>
+    <p:spTree>
+      <p:nvGrpSpPr>
+        <p:cNvPr id="1" name=""/>
+        <p:cNvGrpSpPr/>
+        <p:nvPr/>
+      </p:nvGrpSpPr>
+      <p:grpSpPr>
+        <a:xfrm>
+          <a:off x="0" y="0"/>
+          <a:ext cx="0" cy="0"/>
+          <a:chOff x="0" y="0"/>
+          <a:chExt cx="0" cy="0"/>
+        </a:xfrm>
+      </p:grpSpPr>
+      <p:sp>
+        <p:nvSpPr>
+          <p:cNvPr id="2" name="投影片影像版面配置區 1"/>
+          <p:cNvSpPr>
+            <a:spLocks noGrp="1" noRot="1" noChangeAspect="1"/>
+          </p:cNvSpPr>
+          <p:nvPr>
+            <p:ph type="sldImg"/>
+          </p:nvPr>
+        </p:nvSpPr>
+        <p:spPr/>
+      </p:sp>
+      <p:sp>
+        <p:nvSpPr>
+          <p:cNvPr id="3" name="備忘稿版面配置區 2"/>
+          <p:cNvSpPr>
+            <a:spLocks noGrp="1"/>
+          </p:cNvSpPr>
+          <p:nvPr>
+            <p:ph type="body" idx="1"/>
+          </p:nvPr>
+        </p:nvSpPr>
+        <p:spPr/>
+        <p:txBody>
+          <a:bodyPr/>
+          <a:lstStyle/>
+          <a:p>
+            <a:r>
+              <a:rPr kumimoji="1" lang="zh-TW" altLang="en-US" dirty="0"/>
+              <a:t>紅線是我們希望模型學到的東西</a:t>
+            </a:r>
+            <a:endParaRPr kumimoji="1" lang="en-US" altLang="zh-TW" dirty="0"/>
+          </a:p>
+          <a:p>
+            <a:r>
+              <a:rPr kumimoji="1" lang="zh-TW" altLang="en-US" dirty="0"/>
+              <a:t>綠線是每次訓練後所 </a:t>
+            </a:r>
+            <a:r>
+              <a:rPr kumimoji="1" lang="en-US" altLang="zh-TW" dirty="0"/>
+              <a:t>fit </a:t>
+            </a:r>
+            <a:r>
+              <a:rPr kumimoji="1" lang="zh-TW" altLang="en-US" dirty="0"/>
+              <a:t>出來的模型</a:t>
+            </a:r>
+            <a:endParaRPr kumimoji="1" lang="en-US" altLang="zh-TW" dirty="0"/>
+          </a:p>
+          <a:p>
+            <a:r>
+              <a:rPr kumimoji="1" lang="en-US" altLang="zh-TW" dirty="0"/>
+              <a:t>Degree 1: </a:t>
+            </a:r>
+            <a:r>
+              <a:rPr kumimoji="1" lang="zh-TW" altLang="en-US" dirty="0"/>
+              <a:t>線幾乎疊在一起很穩定，但都是直線永遠畫不出紅線的那個樣子，這就是 </a:t>
+            </a:r>
+            <a:r>
+              <a:rPr kumimoji="1" lang="en-US" altLang="zh-TW" dirty="0"/>
+              <a:t>high bias </a:t>
+            </a:r>
+            <a:r>
+              <a:rPr kumimoji="1" lang="zh-TW" altLang="en-US" dirty="0"/>
+              <a:t>模型太簡單，資料不管怎麼換，永遠學不到真正的趨勢</a:t>
+            </a:r>
+            <a:endParaRPr kumimoji="1" lang="en-US" altLang="zh-TW" dirty="0"/>
+          </a:p>
+          <a:p>
+            <a:r>
+              <a:rPr kumimoji="1" lang="en-US" altLang="zh-TW" dirty="0"/>
+              <a:t>Degree 3: </a:t>
+            </a:r>
+            <a:r>
+              <a:rPr kumimoji="1" lang="zh-TW" altLang="en-US" dirty="0"/>
+              <a:t>綠線貼著紅線很接近，剛剛好的模型複雜度</a:t>
+            </a:r>
+            <a:endParaRPr kumimoji="1" lang="en-US" altLang="zh-TW" dirty="0"/>
+          </a:p>
+          <a:p>
+            <a:r>
+              <a:rPr kumimoji="1" lang="en-US" altLang="zh-TW" dirty="0"/>
+              <a:t>Degree 10: </a:t>
+            </a:r>
+            <a:r>
+              <a:rPr kumimoji="1" lang="zh-TW" altLang="en-US" dirty="0"/>
+              <a:t>雖然有接近紅線的，但可以看到每條在亂飄，代表模型是有能力學到真正的趨勢但不穩定，這就是 </a:t>
+            </a:r>
+            <a:r>
+              <a:rPr kumimoji="1" lang="en-US" altLang="zh-TW" dirty="0"/>
+              <a:t>high variance</a:t>
+            </a:r>
+          </a:p>
+          <a:p>
+            <a:r>
+              <a:rPr lang="zh-TW" altLang="zh-TW" dirty="0"/>
+              <a:t>模型太複雜，連訓練資料裡的雜訊都一起記下來了，所以換一批資料，結果就差很多。</a:t>
+            </a:r>
+            <a:endParaRPr lang="en-US" altLang="zh-TW" dirty="0"/>
+          </a:p>
+          <a:p>
+            <a:endParaRPr kumimoji="1" lang="en-US" altLang="zh-TW" dirty="0"/>
+          </a:p>
+          <a:p>
+            <a:r>
+              <a:rPr kumimoji="1" lang="zh-TW" altLang="en-US" dirty="0"/>
+              <a:t>這張圖的問題：現實中不會知道紅線長怎樣，</a:t>
+            </a:r>
+            <a:r>
+              <a:rPr lang="zh-TW" altLang="zh-TW" dirty="0"/>
+              <a:t>所以沒辦法直接判斷模型好不好</a:t>
+            </a:r>
+            <a:endParaRPr kumimoji="1" lang="en-US" altLang="zh-TW" dirty="0"/>
+          </a:p>
+        </p:txBody>
+      </p:sp>
+      <p:sp>
+        <p:nvSpPr>
+          <p:cNvPr id="4" name="投影片編號版面配置區 3"/>
+          <p:cNvSpPr>
+            <a:spLocks noGrp="1"/>
+          </p:cNvSpPr>
+          <p:nvPr>
+            <p:ph type="sldNum" sz="quarter" idx="5"/>
+          </p:nvPr>
+        </p:nvSpPr>
+        <p:spPr/>
+        <p:txBody>
+          <a:bodyPr/>
+          <a:lstStyle/>
+          <a:p>
+            <a:fld id="{5C1B2D8A-08BB-564F-B065-2252CD015E6C}" type="slidenum">
+              <a:rPr kumimoji="1" lang="zh-TW" altLang="en-US" smtClean="0"/>
+              <a:t>7</a:t>
+            </a:fld>
+            <a:endParaRPr kumimoji="1" lang="zh-TW" altLang="en-US"/>
+          </a:p>
+        </p:txBody>
+      </p:sp>
+    </p:spTree>
+    <p:extLst>
+      <p:ext uri="{BB962C8B-B14F-4D97-AF65-F5344CB8AC3E}">
+        <p14:creationId xmlns:p14="http://schemas.microsoft.com/office/powerpoint/2010/main" val="2425379342"/>
+      </p:ext>
+    </p:extLst>
+  </p:cSld>
+  <p:clrMapOvr>
+    <a:masterClrMapping/>
+  </p:clrMapOvr>
+</p:notes>
+</file>
+
+<file path=ppt/notesSlides/notesSlide4.xml><?xml version="1.0" encoding="utf-8"?>
+<p:notes xmlns:a="http://schemas.openxmlformats.org/drawingml/2006/main" xmlns:r="http://schemas.openxmlformats.org/officeDocument/2006/relationships" xmlns:p="http://schemas.openxmlformats.org/presentationml/2006/main">
+  <p:cSld>
+    <p:spTree>
+      <p:nvGrpSpPr>
+        <p:cNvPr id="1" name=""/>
+        <p:cNvGrpSpPr/>
+        <p:nvPr/>
+      </p:nvGrpSpPr>
+      <p:grpSpPr>
+        <a:xfrm>
+          <a:off x="0" y="0"/>
+          <a:ext cx="0" cy="0"/>
+          <a:chOff x="0" y="0"/>
+          <a:chExt cx="0" cy="0"/>
+        </a:xfrm>
+      </p:grpSpPr>
+      <p:sp>
+        <p:nvSpPr>
+          <p:cNvPr id="2" name="投影片影像版面配置區 1"/>
+          <p:cNvSpPr>
+            <a:spLocks noGrp="1" noRot="1" noChangeAspect="1"/>
+          </p:cNvSpPr>
+          <p:nvPr>
+            <p:ph type="sldImg"/>
+          </p:nvPr>
+        </p:nvSpPr>
+        <p:spPr/>
+      </p:sp>
+      <p:sp>
+        <p:nvSpPr>
+          <p:cNvPr id="3" name="備忘稿版面配置區 2"/>
+          <p:cNvSpPr>
+            <a:spLocks noGrp="1"/>
+          </p:cNvSpPr>
+          <p:nvPr>
+            <p:ph type="body" idx="1"/>
+          </p:nvPr>
+        </p:nvSpPr>
+        <p:spPr/>
+        <p:txBody>
+          <a:bodyPr/>
+          <a:lstStyle/>
+          <a:p>
+            <a:r>
+              <a:rPr kumimoji="1" lang="zh-TW" altLang="en-US" dirty="0"/>
+              <a:t>所以可以用兩個替代的指標來看，分別是 </a:t>
+            </a:r>
+            <a:r>
+              <a:rPr kumimoji="1" lang="en-US" altLang="zh-TW" dirty="0"/>
+              <a:t>training error </a:t>
+            </a:r>
+            <a:r>
+              <a:rPr kumimoji="1" lang="zh-TW" altLang="en-US" dirty="0"/>
+              <a:t>和 </a:t>
+            </a:r>
+            <a:r>
+              <a:rPr kumimoji="1" lang="en-US" altLang="zh-TW" dirty="0"/>
+              <a:t>testing error</a:t>
+            </a:r>
+          </a:p>
+          <a:p>
+            <a:pPr lvl="0"/>
+            <a:r>
+              <a:rPr lang="zh-TW" altLang="zh-TW" b="1" dirty="0"/>
+              <a:t>Training error</a:t>
+            </a:r>
+            <a:r>
+              <a:rPr lang="zh-TW" altLang="zh-TW" dirty="0"/>
+              <a:t>：模型在訓練資料上的 MSE，代表模型把</a:t>
+            </a:r>
+            <a:r>
+              <a:rPr lang="zh-TW" altLang="zh-TW" b="1" dirty="0"/>
+              <a:t>看過的</a:t>
+            </a:r>
+            <a:r>
+              <a:rPr lang="zh-TW" altLang="zh-TW" dirty="0"/>
+              <a:t>資料記得多好。</a:t>
+            </a:r>
+          </a:p>
+          <a:p>
+            <a:pPr lvl="0"/>
+            <a:r>
+              <a:rPr lang="zh-TW" altLang="zh-TW" b="1" dirty="0"/>
+              <a:t>Testing error</a:t>
+            </a:r>
+            <a:r>
+              <a:rPr lang="zh-TW" altLang="zh-TW" dirty="0"/>
+              <a:t>：模型在</a:t>
+            </a:r>
+            <a:r>
+              <a:rPr lang="zh-TW" altLang="zh-TW" b="1" dirty="0"/>
+              <a:t>沒看過的</a:t>
+            </a:r>
+            <a:r>
+              <a:rPr lang="zh-TW" altLang="zh-TW" dirty="0"/>
+              <a:t>資料上的 MSE。</a:t>
+            </a:r>
+            <a:endParaRPr lang="en-US" altLang="zh-TW" dirty="0"/>
+          </a:p>
+          <a:p>
+            <a:pPr lvl="0"/>
+            <a:r>
+              <a:rPr kumimoji="1" lang="zh-TW" altLang="en-US" dirty="0"/>
+              <a:t>可以從途中看到一開始兩個 </a:t>
+            </a:r>
+            <a:r>
+              <a:rPr kumimoji="1" lang="en-US" altLang="zh-TW" dirty="0" err="1"/>
+              <a:t>mse</a:t>
+            </a:r>
+            <a:r>
+              <a:rPr kumimoji="1" lang="en-US" altLang="zh-TW" dirty="0"/>
+              <a:t> </a:t>
+            </a:r>
+            <a:r>
+              <a:rPr kumimoji="1" lang="zh-TW" altLang="en-US" dirty="0"/>
+              <a:t>都很高，可以判斷出是 </a:t>
+            </a:r>
+            <a:r>
+              <a:rPr kumimoji="1" lang="en-US" altLang="zh-TW" dirty="0"/>
+              <a:t>underfit</a:t>
+            </a:r>
+          </a:p>
+          <a:p>
+            <a:pPr lvl="0"/>
+            <a:r>
+              <a:rPr kumimoji="1" lang="zh-TW" altLang="en-US" dirty="0"/>
+              <a:t>中間兩個幾乎疊在一起的地方，可以判斷出是模型複雜度剛剛好的</a:t>
+            </a:r>
+            <a:endParaRPr kumimoji="1" lang="en-US" altLang="zh-TW" dirty="0"/>
+          </a:p>
+          <a:p>
+            <a:pPr lvl="0"/>
+            <a:r>
+              <a:rPr kumimoji="1" lang="zh-TW" altLang="en-US" dirty="0"/>
+              <a:t>後面可以看到 </a:t>
+            </a:r>
+            <a:r>
+              <a:rPr kumimoji="1" lang="en-US" altLang="zh-TW" dirty="0"/>
+              <a:t>training error </a:t>
+            </a:r>
+            <a:r>
+              <a:rPr kumimoji="1" lang="zh-TW" altLang="en-US" dirty="0"/>
+              <a:t>很低，但 </a:t>
+            </a:r>
+            <a:r>
+              <a:rPr kumimoji="1" lang="en-US" altLang="zh-TW" dirty="0"/>
+              <a:t>testing error </a:t>
+            </a:r>
+            <a:r>
+              <a:rPr kumimoji="1" lang="zh-TW" altLang="en-US" dirty="0"/>
+              <a:t>和他有差距，可以判斷出是 </a:t>
+            </a:r>
+            <a:r>
+              <a:rPr kumimoji="1" lang="en-US" altLang="zh-TW" dirty="0"/>
+              <a:t>overfit</a:t>
+            </a:r>
+            <a:endParaRPr kumimoji="1" lang="zh-TW" altLang="en-US" dirty="0"/>
+          </a:p>
+        </p:txBody>
+      </p:sp>
+      <p:sp>
+        <p:nvSpPr>
+          <p:cNvPr id="4" name="投影片編號版面配置區 3"/>
+          <p:cNvSpPr>
+            <a:spLocks noGrp="1"/>
+          </p:cNvSpPr>
+          <p:nvPr>
+            <p:ph type="sldNum" sz="quarter" idx="5"/>
+          </p:nvPr>
+        </p:nvSpPr>
+        <p:spPr/>
+        <p:txBody>
+          <a:bodyPr/>
+          <a:lstStyle/>
+          <a:p>
+            <a:fld id="{5C1B2D8A-08BB-564F-B065-2252CD015E6C}" type="slidenum">
+              <a:rPr kumimoji="1" lang="zh-TW" altLang="en-US" smtClean="0"/>
+              <a:t>8</a:t>
+            </a:fld>
+            <a:endParaRPr kumimoji="1" lang="zh-TW" altLang="en-US"/>
+          </a:p>
+        </p:txBody>
+      </p:sp>
+    </p:spTree>
+    <p:extLst>
+      <p:ext uri="{BB962C8B-B14F-4D97-AF65-F5344CB8AC3E}">
+        <p14:creationId xmlns:p14="http://schemas.microsoft.com/office/powerpoint/2010/main" val="1803388600"/>
+      </p:ext>
+    </p:extLst>
+  </p:cSld>
+  <p:clrMapOvr>
+    <a:masterClrMapping/>
+  </p:clrMapOvr>
+</p:notes>
+</file>
+
+<file path=ppt/notesSlides/notesSlide5.xml><?xml version="1.0" encoding="utf-8"?>
+<p:notes xmlns:a="http://schemas.openxmlformats.org/drawingml/2006/main" xmlns:r="http://schemas.openxmlformats.org/officeDocument/2006/relationships" xmlns:p="http://schemas.openxmlformats.org/presentationml/2006/main">
+  <p:cSld>
+    <p:spTree>
+      <p:nvGrpSpPr>
+        <p:cNvPr id="1" name=""/>
+        <p:cNvGrpSpPr/>
+        <p:nvPr/>
+      </p:nvGrpSpPr>
+      <p:grpSpPr>
+        <a:xfrm>
+          <a:off x="0" y="0"/>
+          <a:ext cx="0" cy="0"/>
+          <a:chOff x="0" y="0"/>
+          <a:chExt cx="0" cy="0"/>
+        </a:xfrm>
+      </p:grpSpPr>
+      <p:sp>
+        <p:nvSpPr>
+          <p:cNvPr id="2" name="投影片影像版面配置區 1"/>
+          <p:cNvSpPr>
+            <a:spLocks noGrp="1" noRot="1" noChangeAspect="1"/>
+          </p:cNvSpPr>
+          <p:nvPr>
+            <p:ph type="sldImg"/>
+          </p:nvPr>
+        </p:nvSpPr>
+        <p:spPr/>
+      </p:sp>
+      <p:sp>
+        <p:nvSpPr>
+          <p:cNvPr id="3" name="備忘稿版面配置區 2"/>
+          <p:cNvSpPr>
+            <a:spLocks noGrp="1"/>
+          </p:cNvSpPr>
+          <p:nvPr>
+            <p:ph type="body" idx="1"/>
+          </p:nvPr>
+        </p:nvSpPr>
+        <p:spPr/>
+        <p:txBody>
+          <a:bodyPr/>
+          <a:lstStyle/>
+          <a:p>
+            <a:r>
+              <a:rPr kumimoji="1" lang="zh-TW" altLang="en-US" dirty="0"/>
+              <a:t>剛剛看的圖有個前提是資料量要夠多</a:t>
+            </a:r>
+            <a:endParaRPr kumimoji="1" lang="en-US" altLang="zh-TW" dirty="0"/>
+          </a:p>
+          <a:p>
+            <a:r>
+              <a:rPr lang="zh-TW" altLang="zh-TW" dirty="0"/>
+              <a:t>如果資料太少，就算模型複雜度剛好，還是會 overfit。所以除了複雜度，我們還要看另一件事：資料夠不夠？</a:t>
+            </a:r>
+            <a:endParaRPr kumimoji="1" lang="zh-TW" altLang="en-US" dirty="0"/>
+          </a:p>
+        </p:txBody>
+      </p:sp>
+      <p:sp>
+        <p:nvSpPr>
+          <p:cNvPr id="4" name="投影片編號版面配置區 3"/>
+          <p:cNvSpPr>
+            <a:spLocks noGrp="1"/>
+          </p:cNvSpPr>
+          <p:nvPr>
+            <p:ph type="sldNum" sz="quarter" idx="5"/>
+          </p:nvPr>
+        </p:nvSpPr>
+        <p:spPr/>
+        <p:txBody>
+          <a:bodyPr/>
+          <a:lstStyle/>
+          <a:p>
+            <a:fld id="{5C1B2D8A-08BB-564F-B065-2252CD015E6C}" type="slidenum">
+              <a:rPr kumimoji="1" lang="zh-TW" altLang="en-US" smtClean="0"/>
+              <a:t>10</a:t>
+            </a:fld>
+            <a:endParaRPr kumimoji="1" lang="zh-TW" altLang="en-US"/>
+          </a:p>
+        </p:txBody>
+      </p:sp>
+    </p:spTree>
+    <p:extLst>
+      <p:ext uri="{BB962C8B-B14F-4D97-AF65-F5344CB8AC3E}">
+        <p14:creationId xmlns:p14="http://schemas.microsoft.com/office/powerpoint/2010/main" val="1099791946"/>
+      </p:ext>
+    </p:extLst>
+  </p:cSld>
+  <p:clrMapOvr>
+    <a:masterClrMapping/>
+  </p:clrMapOvr>
+</p:notes>
+</file>
+
+<file path=ppt/notesSlides/notesSlide6.xml><?xml version="1.0" encoding="utf-8"?>
+<p:notes xmlns:a="http://schemas.openxmlformats.org/drawingml/2006/main" xmlns:r="http://schemas.openxmlformats.org/officeDocument/2006/relationships" xmlns:p="http://schemas.openxmlformats.org/presentationml/2006/main">
+  <p:cSld>
+    <p:spTree>
+      <p:nvGrpSpPr>
+        <p:cNvPr id="1" name=""/>
+        <p:cNvGrpSpPr/>
+        <p:nvPr/>
+      </p:nvGrpSpPr>
+      <p:grpSpPr>
+        <a:xfrm>
+          <a:off x="0" y="0"/>
+          <a:ext cx="0" cy="0"/>
+          <a:chOff x="0" y="0"/>
+          <a:chExt cx="0" cy="0"/>
+        </a:xfrm>
+      </p:grpSpPr>
+      <p:sp>
+        <p:nvSpPr>
+          <p:cNvPr id="2" name="投影片影像版面配置區 1"/>
+          <p:cNvSpPr>
+            <a:spLocks noGrp="1" noRot="1" noChangeAspect="1"/>
+          </p:cNvSpPr>
+          <p:nvPr>
+            <p:ph type="sldImg"/>
+          </p:nvPr>
+        </p:nvSpPr>
+        <p:spPr/>
+      </p:sp>
+      <p:sp>
+        <p:nvSpPr>
+          <p:cNvPr id="3" name="備忘稿版面配置區 2"/>
+          <p:cNvSpPr>
+            <a:spLocks noGrp="1"/>
+          </p:cNvSpPr>
+          <p:nvPr>
+            <p:ph type="body" idx="1"/>
+          </p:nvPr>
+        </p:nvSpPr>
+        <p:spPr/>
+        <p:txBody>
+          <a:bodyPr/>
+          <a:lstStyle/>
+          <a:p>
+            <a:r>
+              <a:rPr kumimoji="1" lang="zh-TW" altLang="en-US" dirty="0"/>
+              <a:t>現在 </a:t>
+            </a:r>
+            <a:r>
+              <a:rPr kumimoji="1" lang="en-US" altLang="zh-TW" dirty="0"/>
+              <a:t>x </a:t>
+            </a:r>
+            <a:r>
+              <a:rPr kumimoji="1" lang="zh-TW" altLang="en-US" dirty="0"/>
+              <a:t>軸變成訓練樣本數，在複雜度固定的情況下，資料越來越多 </a:t>
+            </a:r>
+            <a:r>
+              <a:rPr kumimoji="1" lang="en-US" altLang="zh-TW" dirty="0"/>
+              <a:t>error </a:t>
+            </a:r>
+            <a:r>
+              <a:rPr kumimoji="1" lang="zh-TW" altLang="en-US" dirty="0"/>
+              <a:t>會怎麼變化</a:t>
+            </a:r>
+            <a:endParaRPr kumimoji="1" lang="en-US" altLang="zh-TW" dirty="0"/>
+          </a:p>
+          <a:p>
+            <a:pPr lvl="0"/>
+            <a:r>
+              <a:rPr lang="zh-TW" altLang="zh-TW" b="0" dirty="0"/>
+              <a:t>Degree 1：資料變多後，兩條線很快靠在一起，但停在紅線上方，下不去。這代表多給資料也沒用，問題是模型太簡單（bias），應該換更複雜的模型。</a:t>
+            </a:r>
+          </a:p>
+          <a:p>
+            <a:pPr lvl="0"/>
+            <a:r>
+              <a:rPr lang="zh-TW" altLang="zh-TW" b="0" dirty="0"/>
+              <a:t>Degree 3：兩條線最後都收斂到紅線附近，這是最理想的狀況。</a:t>
+            </a:r>
+          </a:p>
+          <a:p>
+            <a:pPr lvl="0"/>
+            <a:r>
+              <a:rPr lang="zh-TW" altLang="zh-TW" b="0" dirty="0"/>
+              <a:t>Degree 10：樣本少的時候，training error 幾乎是 0，</a:t>
+            </a:r>
+            <a:r>
+              <a:rPr lang="zh-TW" altLang="zh-TW" b="0" dirty="0">
+                <a:highlight>
+                  <a:srgbClr val="FFFF00"/>
+                </a:highlight>
+              </a:rPr>
+              <a:t>testing error 高到衝出圖外，這是嚴重的 overfit。資料變多後，兩條線慢慢靠近，但到 80 筆時還有差距。這代表再多給資料會有幫助，問題是 variance。</a:t>
+            </a:r>
+          </a:p>
+          <a:p>
+            <a:endParaRPr kumimoji="1" lang="zh-TW" altLang="en-US" dirty="0"/>
+          </a:p>
+        </p:txBody>
+      </p:sp>
+      <p:sp>
+        <p:nvSpPr>
+          <p:cNvPr id="4" name="投影片編號版面配置區 3"/>
+          <p:cNvSpPr>
+            <a:spLocks noGrp="1"/>
+          </p:cNvSpPr>
+          <p:nvPr>
+            <p:ph type="sldNum" sz="quarter" idx="5"/>
+          </p:nvPr>
+        </p:nvSpPr>
+        <p:spPr/>
+        <p:txBody>
+          <a:bodyPr/>
+          <a:lstStyle/>
+          <a:p>
+            <a:fld id="{5C1B2D8A-08BB-564F-B065-2252CD015E6C}" type="slidenum">
+              <a:rPr kumimoji="1" lang="zh-TW" altLang="en-US" smtClean="0"/>
+              <a:t>11</a:t>
+            </a:fld>
+            <a:endParaRPr kumimoji="1" lang="zh-TW" altLang="en-US"/>
+          </a:p>
+        </p:txBody>
+      </p:sp>
+    </p:spTree>
+    <p:extLst>
+      <p:ext uri="{BB962C8B-B14F-4D97-AF65-F5344CB8AC3E}">
+        <p14:creationId xmlns:p14="http://schemas.microsoft.com/office/powerpoint/2010/main" val="1531410368"/>
+      </p:ext>
+    </p:extLst>
+  </p:cSld>
+  <p:clrMapOvr>
+    <a:masterClrMapping/>
+  </p:clrMapOvr>
+</p:notes>
+</file>
+
+<file path=ppt/notesSlides/notesSlide7.xml><?xml version="1.0" encoding="utf-8"?>
+<p:notes xmlns:a="http://schemas.openxmlformats.org/drawingml/2006/main" xmlns:r="http://schemas.openxmlformats.org/officeDocument/2006/relationships" xmlns:p="http://schemas.openxmlformats.org/presentationml/2006/main">
+  <p:cSld>
+    <p:spTree>
+      <p:nvGrpSpPr>
+        <p:cNvPr id="1" name=""/>
+        <p:cNvGrpSpPr/>
+        <p:nvPr/>
+      </p:nvGrpSpPr>
+      <p:grpSpPr>
+        <a:xfrm>
+          <a:off x="0" y="0"/>
+          <a:ext cx="0" cy="0"/>
+          <a:chOff x="0" y="0"/>
+          <a:chExt cx="0" cy="0"/>
+        </a:xfrm>
+      </p:grpSpPr>
+      <p:sp>
+        <p:nvSpPr>
+          <p:cNvPr id="2" name="投影片影像版面配置區 1"/>
+          <p:cNvSpPr>
+            <a:spLocks noGrp="1" noRot="1" noChangeAspect="1"/>
+          </p:cNvSpPr>
+          <p:nvPr>
+            <p:ph type="sldImg"/>
+          </p:nvPr>
+        </p:nvSpPr>
+        <p:spPr/>
+      </p:sp>
+      <p:sp>
+        <p:nvSpPr>
+          <p:cNvPr id="3" name="備忘稿版面配置區 2"/>
+          <p:cNvSpPr>
+            <a:spLocks noGrp="1"/>
+          </p:cNvSpPr>
+          <p:nvPr>
+            <p:ph type="body" idx="1"/>
+          </p:nvPr>
+        </p:nvSpPr>
+        <p:spPr/>
+        <p:txBody>
+          <a:bodyPr/>
+          <a:lstStyle/>
+          <a:p>
+            <a:r>
+              <a:rPr kumimoji="1" lang="zh-TW" altLang="en-US" dirty="0"/>
+              <a:t>解決 </a:t>
+            </a:r>
+            <a:r>
+              <a:rPr kumimoji="1" lang="en-US" altLang="zh-TW" dirty="0"/>
+              <a:t>overfit </a:t>
+            </a:r>
+            <a:r>
+              <a:rPr kumimoji="1" lang="zh-TW" altLang="en-US" dirty="0"/>
+              <a:t>問題有兩種方法：增加資料或降低模型複雜度</a:t>
+            </a:r>
+            <a:endParaRPr kumimoji="1" lang="en-US" altLang="zh-TW" dirty="0"/>
+          </a:p>
+          <a:p>
+            <a:r>
+              <a:rPr lang="en-US" altLang="zh-TW" sz="1200" b="0" i="0" kern="1200" dirty="0">
+                <a:solidFill>
+                  <a:schemeClr val="tx1"/>
+                </a:solidFill>
+                <a:effectLst/>
+                <a:latin typeface="+mn-lt"/>
+                <a:ea typeface="+mn-ea"/>
+                <a:cs typeface="+mn-cs"/>
+              </a:rPr>
+              <a:t>Weight decay </a:t>
+            </a:r>
+            <a:r>
+              <a:rPr lang="zh-TW" altLang="zh-TW" sz="1200" b="0" i="0" kern="1200" dirty="0">
+                <a:solidFill>
+                  <a:schemeClr val="tx1"/>
+                </a:solidFill>
+                <a:effectLst/>
+                <a:latin typeface="+mn-lt"/>
+                <a:ea typeface="+mn-ea"/>
+                <a:cs typeface="+mn-cs"/>
+              </a:rPr>
+              <a:t>是透過對模型中的權重參數施加懲罰，限制其數值的大小，從而降低模型的複雜度。</a:t>
+            </a:r>
+            <a:endParaRPr kumimoji="1" lang="en-US" altLang="zh-TW" dirty="0"/>
+          </a:p>
+          <a:p>
+            <a:endParaRPr kumimoji="1" lang="zh-TW" altLang="en-US" dirty="0"/>
+          </a:p>
+        </p:txBody>
+      </p:sp>
+      <p:sp>
+        <p:nvSpPr>
+          <p:cNvPr id="4" name="投影片編號版面配置區 3"/>
+          <p:cNvSpPr>
+            <a:spLocks noGrp="1"/>
+          </p:cNvSpPr>
+          <p:nvPr>
+            <p:ph type="sldNum" sz="quarter" idx="5"/>
+          </p:nvPr>
+        </p:nvSpPr>
+        <p:spPr/>
+        <p:txBody>
+          <a:bodyPr/>
+          <a:lstStyle/>
+          <a:p>
+            <a:fld id="{5C1B2D8A-08BB-564F-B065-2252CD015E6C}" type="slidenum">
+              <a:rPr kumimoji="1" lang="zh-TW" altLang="en-US" smtClean="0"/>
+              <a:t>12</a:t>
+            </a:fld>
+            <a:endParaRPr kumimoji="1" lang="zh-TW" altLang="en-US"/>
+          </a:p>
+        </p:txBody>
+      </p:sp>
+    </p:spTree>
+    <p:extLst>
+      <p:ext uri="{BB962C8B-B14F-4D97-AF65-F5344CB8AC3E}">
+        <p14:creationId xmlns:p14="http://schemas.microsoft.com/office/powerpoint/2010/main" val="2997791952"/>
+      </p:ext>
+    </p:extLst>
+  </p:cSld>
+  <p:clrMapOvr>
+    <a:masterClrMapping/>
+  </p:clrMapOvr>
+</p:notes>
+</file>
+
+<file path=ppt/notesSlides/notesSlide8.xml><?xml version="1.0" encoding="utf-8"?>
+<p:notes xmlns:a="http://schemas.openxmlformats.org/drawingml/2006/main" xmlns:r="http://schemas.openxmlformats.org/officeDocument/2006/relationships" xmlns:p="http://schemas.openxmlformats.org/presentationml/2006/main">
+  <p:cSld>
+    <p:spTree>
+      <p:nvGrpSpPr>
+        <p:cNvPr id="1" name=""/>
+        <p:cNvGrpSpPr/>
+        <p:nvPr/>
+      </p:nvGrpSpPr>
+      <p:grpSpPr>
+        <a:xfrm>
+          <a:off x="0" y="0"/>
+          <a:ext cx="0" cy="0"/>
+          <a:chOff x="0" y="0"/>
+          <a:chExt cx="0" cy="0"/>
+        </a:xfrm>
+      </p:grpSpPr>
+      <p:sp>
+        <p:nvSpPr>
+          <p:cNvPr id="2" name="投影片影像版面配置區 1"/>
+          <p:cNvSpPr>
+            <a:spLocks noGrp="1" noRot="1" noChangeAspect="1"/>
+          </p:cNvSpPr>
+          <p:nvPr>
+            <p:ph type="sldImg"/>
+          </p:nvPr>
+        </p:nvSpPr>
+        <p:spPr/>
+      </p:sp>
+      <p:sp>
+        <p:nvSpPr>
+          <p:cNvPr id="3" name="備忘稿版面配置區 2"/>
+          <p:cNvSpPr>
+            <a:spLocks noGrp="1"/>
+          </p:cNvSpPr>
+          <p:nvPr>
+            <p:ph type="body" idx="1"/>
+          </p:nvPr>
+        </p:nvSpPr>
+        <p:spPr/>
+        <p:txBody>
+          <a:bodyPr/>
+          <a:lstStyle/>
+          <a:p>
+            <a:r>
+              <a:rPr kumimoji="1" lang="en-US" altLang="zh-TW" dirty="0"/>
+              <a:t>Weight decay </a:t>
+            </a:r>
+            <a:r>
+              <a:rPr kumimoji="1" lang="zh-TW" altLang="en-US" dirty="0"/>
+              <a:t>就是在原本的 </a:t>
+            </a:r>
+            <a:r>
+              <a:rPr kumimoji="1" lang="en-US" altLang="zh-TW" dirty="0"/>
+              <a:t>cost function </a:t>
+            </a:r>
+            <a:r>
+              <a:rPr kumimoji="1" lang="zh-TW" altLang="en-US" dirty="0"/>
+              <a:t>後面多加一個懲罰項 </a:t>
+            </a:r>
+            <a:endParaRPr kumimoji="1" lang="en-US" altLang="zh-TW" dirty="0"/>
+          </a:p>
+          <a:p>
+            <a:r>
+              <a:rPr kumimoji="1" lang="zh-TW" altLang="en-US" dirty="0"/>
+              <a:t>這邊會提到兩個分別是 </a:t>
+            </a:r>
+            <a:r>
+              <a:rPr kumimoji="1" lang="en-US" altLang="zh-TW" dirty="0"/>
+              <a:t>ridge regression </a:t>
+            </a:r>
+            <a:r>
+              <a:rPr kumimoji="1" lang="zh-TW" altLang="en-US" dirty="0"/>
+              <a:t>和 </a:t>
+            </a:r>
+            <a:r>
+              <a:rPr kumimoji="1" lang="en-US" altLang="zh-TW" dirty="0"/>
+              <a:t>lasso</a:t>
+            </a:r>
+            <a:endParaRPr kumimoji="1" lang="zh-TW" altLang="en-US" dirty="0"/>
+          </a:p>
+        </p:txBody>
+      </p:sp>
+      <p:sp>
+        <p:nvSpPr>
+          <p:cNvPr id="4" name="投影片編號版面配置區 3"/>
+          <p:cNvSpPr>
+            <a:spLocks noGrp="1"/>
+          </p:cNvSpPr>
+          <p:nvPr>
+            <p:ph type="sldNum" sz="quarter" idx="5"/>
+          </p:nvPr>
+        </p:nvSpPr>
+        <p:spPr/>
+        <p:txBody>
+          <a:bodyPr/>
+          <a:lstStyle/>
+          <a:p>
+            <a:fld id="{5C1B2D8A-08BB-564F-B065-2252CD015E6C}" type="slidenum">
+              <a:rPr kumimoji="1" lang="zh-TW" altLang="en-US" smtClean="0"/>
+              <a:t>13</a:t>
+            </a:fld>
+            <a:endParaRPr kumimoji="1" lang="zh-TW" altLang="en-US"/>
+          </a:p>
+        </p:txBody>
+      </p:sp>
+    </p:spTree>
+    <p:extLst>
+      <p:ext uri="{BB962C8B-B14F-4D97-AF65-F5344CB8AC3E}">
+        <p14:creationId xmlns:p14="http://schemas.microsoft.com/office/powerpoint/2010/main" val="916834033"/>
+      </p:ext>
+    </p:extLst>
+  </p:cSld>
+  <p:clrMapOvr>
+    <a:masterClrMapping/>
+  </p:clrMapOvr>
+</p:notes>
+</file>
+
+<file path=ppt/notesSlides/notesSlide9.xml><?xml version="1.0" encoding="utf-8"?>
+<p:notes xmlns:a="http://schemas.openxmlformats.org/drawingml/2006/main" xmlns:r="http://schemas.openxmlformats.org/officeDocument/2006/relationships" xmlns:p="http://schemas.openxmlformats.org/presentationml/2006/main">
+  <p:cSld>
+    <p:spTree>
+      <p:nvGrpSpPr>
+        <p:cNvPr id="1" name=""/>
+        <p:cNvGrpSpPr/>
+        <p:nvPr/>
+      </p:nvGrpSpPr>
+      <p:grpSpPr>
+        <a:xfrm>
+          <a:off x="0" y="0"/>
+          <a:ext cx="0" cy="0"/>
+          <a:chOff x="0" y="0"/>
+          <a:chExt cx="0" cy="0"/>
+        </a:xfrm>
+      </p:grpSpPr>
+      <p:sp>
+        <p:nvSpPr>
+          <p:cNvPr id="2" name="投影片影像版面配置區 1"/>
+          <p:cNvSpPr>
+            <a:spLocks noGrp="1" noRot="1" noChangeAspect="1"/>
+          </p:cNvSpPr>
+          <p:nvPr>
+            <p:ph type="sldImg"/>
+          </p:nvPr>
+        </p:nvSpPr>
+        <p:spPr/>
+      </p:sp>
+      <p:sp>
+        <p:nvSpPr>
+          <p:cNvPr id="3" name="備忘稿版面配置區 2"/>
+          <p:cNvSpPr>
+            <a:spLocks noGrp="1"/>
+          </p:cNvSpPr>
+          <p:nvPr>
+            <p:ph type="body" idx="1"/>
+          </p:nvPr>
+        </p:nvSpPr>
+        <p:spPr/>
+        <p:txBody>
+          <a:bodyPr/>
+          <a:lstStyle/>
+          <a:p>
+            <a:pPr rtl="0"/>
+            <a:r>
+              <a:rPr lang="zh-TW" altLang="zh-TW" b="0" dirty="0"/>
+              <a:t>α = 0，也就是沒有懲罰。Training MSE 是 0，完全記住訓練資料；testing MSE 卻是將近 兩萬。這是非常嚴重的 overfit。</a:t>
+            </a:r>
+          </a:p>
+          <a:p>
+            <a:pPr rtl="0"/>
+            <a:r>
+              <a:rPr lang="zh-TW" altLang="zh-TW" b="0" dirty="0"/>
+              <a:t>α = 1，只加一點點懲罰，testing MSE 就從兩萬掉到 23。</a:t>
+            </a:r>
+          </a:p>
+          <a:p>
+            <a:pPr rtl="0"/>
+            <a:r>
+              <a:rPr lang="zh-TW" altLang="zh-TW" b="0" dirty="0"/>
+              <a:t>α = 10、100，testing MSE 繼續下降，在 α = 100 時最低，是 15.16。</a:t>
+            </a:r>
+          </a:p>
+          <a:p>
+            <a:pPr rtl="0"/>
+            <a:r>
+              <a:rPr lang="zh-TW" altLang="zh-TW" b="0" dirty="0"/>
+              <a:t>α = 1000，testing MSE 又回升到 19。看 training MSE，從 3.6 升到 8.8，表示連訓練資料都學不好了</a:t>
+            </a:r>
+            <a:r>
+              <a:rPr lang="zh-TW" altLang="en-US" b="0" dirty="0"/>
+              <a:t>，</a:t>
+            </a:r>
+            <a:r>
+              <a:rPr lang="zh-TW" altLang="zh-TW" b="0" dirty="0"/>
+              <a:t>變成 underfit。</a:t>
+            </a:r>
+          </a:p>
+          <a:p>
+            <a:endParaRPr kumimoji="1" lang="zh-TW" altLang="en-US" b="0" dirty="0"/>
+          </a:p>
+        </p:txBody>
+      </p:sp>
+      <p:sp>
+        <p:nvSpPr>
+          <p:cNvPr id="4" name="投影片編號版面配置區 3"/>
+          <p:cNvSpPr>
+            <a:spLocks noGrp="1"/>
+          </p:cNvSpPr>
+          <p:nvPr>
+            <p:ph type="sldNum" sz="quarter" idx="5"/>
+          </p:nvPr>
+        </p:nvSpPr>
+        <p:spPr/>
+        <p:txBody>
+          <a:bodyPr/>
+          <a:lstStyle/>
+          <a:p>
+            <a:fld id="{5C1B2D8A-08BB-564F-B065-2252CD015E6C}" type="slidenum">
+              <a:rPr kumimoji="1" lang="zh-TW" altLang="en-US" smtClean="0"/>
+              <a:t>14</a:t>
+            </a:fld>
+            <a:endParaRPr kumimoji="1" lang="zh-TW" altLang="en-US"/>
+          </a:p>
+        </p:txBody>
+      </p:sp>
+    </p:spTree>
+    <p:extLst>
+      <p:ext uri="{BB962C8B-B14F-4D97-AF65-F5344CB8AC3E}">
+        <p14:creationId xmlns:p14="http://schemas.microsoft.com/office/powerpoint/2010/main" val="2890389933"/>
+      </p:ext>
+    </p:extLst>
+  </p:cSld>
+  <p:clrMapOvr>
+    <a:masterClrMapping/>
+  </p:clrMapOvr>
+</p:notes>
+</file>
+
 <file path=ppt/slideLayouts/slideLayout1.xml><?xml version="1.0" encoding="utf-8"?>
 <p:sldLayout xmlns:a="http://schemas.openxmlformats.org/drawingml/2006/main" xmlns:r="http://schemas.openxmlformats.org/officeDocument/2006/relationships" xmlns:p="http://schemas.openxmlformats.org/presentationml/2006/main" type="title" preserve="1">
   <p:cSld name="標題投影片">
@@ -283,7 +2112,7 @@
           <a:p>
             <a:fld id="{4765E3D6-48E5-4EF2-95BB-FFAB055F7B0D}" type="datetimeFigureOut">
               <a:rPr lang="zh-TW" altLang="en-US" smtClean="0"/>
-              <a:t>2025/9/18</a:t>
+              <a:t>2026/9/24</a:t>
             </a:fld>
             <a:endParaRPr lang="zh-TW" altLang="en-US"/>
           </a:p>
@@ -481,7 +2310,7 @@
           <a:p>
             <a:fld id="{4765E3D6-48E5-4EF2-95BB-FFAB055F7B0D}" type="datetimeFigureOut">
               <a:rPr lang="zh-TW" altLang="en-US" smtClean="0"/>
-              <a:t>2025/9/18</a:t>
+              <a:t>2026/9/24</a:t>
             </a:fld>
             <a:endParaRPr lang="zh-TW" altLang="en-US"/>
           </a:p>
@@ -689,7 +2518,7 @@
           <a:p>
             <a:fld id="{4765E3D6-48E5-4EF2-95BB-FFAB055F7B0D}" type="datetimeFigureOut">
               <a:rPr lang="zh-TW" altLang="en-US" smtClean="0"/>
-              <a:t>2025/9/18</a:t>
+              <a:t>2026/9/24</a:t>
             </a:fld>
             <a:endParaRPr lang="zh-TW" altLang="en-US"/>
           </a:p>
@@ -887,7 +2716,7 @@
           <a:p>
             <a:fld id="{4765E3D6-48E5-4EF2-95BB-FFAB055F7B0D}" type="datetimeFigureOut">
               <a:rPr lang="zh-TW" altLang="en-US" smtClean="0"/>
-              <a:t>2025/9/18</a:t>
+              <a:t>2026/9/24</a:t>
             </a:fld>
             <a:endParaRPr lang="zh-TW" altLang="en-US"/>
           </a:p>
@@ -1162,7 +2991,7 @@
           <a:p>
             <a:fld id="{4765E3D6-48E5-4EF2-95BB-FFAB055F7B0D}" type="datetimeFigureOut">
               <a:rPr lang="zh-TW" altLang="en-US" smtClean="0"/>
-              <a:t>2025/9/18</a:t>
+              <a:t>2026/9/24</a:t>
             </a:fld>
             <a:endParaRPr lang="zh-TW" altLang="en-US"/>
           </a:p>
@@ -1427,7 +3256,7 @@
           <a:p>
             <a:fld id="{4765E3D6-48E5-4EF2-95BB-FFAB055F7B0D}" type="datetimeFigureOut">
               <a:rPr lang="zh-TW" altLang="en-US" smtClean="0"/>
-              <a:t>2025/9/18</a:t>
+              <a:t>2026/9/24</a:t>
             </a:fld>
             <a:endParaRPr lang="zh-TW" altLang="en-US"/>
           </a:p>
@@ -1839,7 +3668,7 @@
           <a:p>
             <a:fld id="{4765E3D6-48E5-4EF2-95BB-FFAB055F7B0D}" type="datetimeFigureOut">
               <a:rPr lang="zh-TW" altLang="en-US" smtClean="0"/>
-              <a:t>2025/9/18</a:t>
+              <a:t>2026/9/24</a:t>
             </a:fld>
             <a:endParaRPr lang="zh-TW" altLang="en-US"/>
           </a:p>
@@ -1980,7 +3809,7 @@
           <a:p>
             <a:fld id="{4765E3D6-48E5-4EF2-95BB-FFAB055F7B0D}" type="datetimeFigureOut">
               <a:rPr lang="zh-TW" altLang="en-US" smtClean="0"/>
-              <a:t>2025/9/18</a:t>
+              <a:t>2026/9/24</a:t>
             </a:fld>
             <a:endParaRPr lang="zh-TW" altLang="en-US"/>
           </a:p>
@@ -2093,7 +3922,7 @@
           <a:p>
             <a:fld id="{4765E3D6-48E5-4EF2-95BB-FFAB055F7B0D}" type="datetimeFigureOut">
               <a:rPr lang="zh-TW" altLang="en-US" smtClean="0"/>
-              <a:t>2025/9/18</a:t>
+              <a:t>2026/9/24</a:t>
             </a:fld>
             <a:endParaRPr lang="zh-TW" altLang="en-US"/>
           </a:p>
@@ -2404,7 +4233,7 @@
           <a:p>
             <a:fld id="{4765E3D6-48E5-4EF2-95BB-FFAB055F7B0D}" type="datetimeFigureOut">
               <a:rPr lang="zh-TW" altLang="en-US" smtClean="0"/>
-              <a:t>2025/9/18</a:t>
+              <a:t>2026/9/24</a:t>
             </a:fld>
             <a:endParaRPr lang="zh-TW" altLang="en-US"/>
           </a:p>
@@ -2692,7 +4521,7 @@
           <a:p>
             <a:fld id="{4765E3D6-48E5-4EF2-95BB-FFAB055F7B0D}" type="datetimeFigureOut">
               <a:rPr lang="zh-TW" altLang="en-US" smtClean="0"/>
-              <a:t>2025/9/18</a:t>
+              <a:t>2026/9/24</a:t>
             </a:fld>
             <a:endParaRPr lang="zh-TW" altLang="en-US"/>
           </a:p>
@@ -2933,7 +4762,7 @@
           <a:p>
             <a:fld id="{4765E3D6-48E5-4EF2-95BB-FFAB055F7B0D}" type="datetimeFigureOut">
               <a:rPr lang="zh-TW" altLang="en-US" smtClean="0"/>
-              <a:t>2025/9/18</a:t>
+              <a:t>2026/9/24</a:t>
             </a:fld>
             <a:endParaRPr lang="zh-TW" altLang="en-US"/>
           </a:p>
@@ -3432,7 +5261,7 @@
                   </a:schemeClr>
                 </a:solidFill>
               </a:rPr>
-              <a:t>, 2025</a:t>
+              <a:t>, 2026</a:t>
             </a:r>
           </a:p>
           <a:p>
@@ -3585,7 +5414,7 @@
           <p:nvPr/>
         </p:nvPicPr>
         <p:blipFill>
-          <a:blip r:embed="rId2">
+          <a:blip r:embed="rId3">
             <a:extLst>
               <a:ext uri="{28A0092B-C50C-407E-A947-70E740481C1C}">
                 <a14:useLocalDpi xmlns:a14="http://schemas.microsoft.com/office/drawing/2010/main" val="0"/>
@@ -3621,7 +5450,7 @@
           <p:nvPr/>
         </p:nvPicPr>
         <p:blipFill rotWithShape="1">
-          <a:blip r:embed="rId3"/>
+          <a:blip r:embed="rId4"/>
           <a:srcRect l="1383" t="10187" r="63222"/>
           <a:stretch/>
         </p:blipFill>
@@ -3755,7 +5584,7 @@
           <p:nvPr/>
         </p:nvPicPr>
         <p:blipFill>
-          <a:blip r:embed="rId2">
+          <a:blip r:embed="rId3">
             <a:extLst>
               <a:ext uri="{28A0092B-C50C-407E-A947-70E740481C1C}">
                 <a14:useLocalDpi xmlns:a14="http://schemas.microsoft.com/office/drawing/2010/main" val="0"/>
@@ -3791,7 +5620,7 @@
           <p:nvPr/>
         </p:nvPicPr>
         <p:blipFill>
-          <a:blip r:embed="rId3">
+          <a:blip r:embed="rId4">
             <a:extLst>
               <a:ext uri="{28A0092B-C50C-407E-A947-70E740481C1C}">
                 <a14:useLocalDpi xmlns:a14="http://schemas.microsoft.com/office/drawing/2010/main" val="0"/>
@@ -3827,7 +5656,7 @@
           <p:nvPr/>
         </p:nvPicPr>
         <p:blipFill>
-          <a:blip r:embed="rId4">
+          <a:blip r:embed="rId5">
             <a:extLst>
               <a:ext uri="{28A0092B-C50C-407E-A947-70E740481C1C}">
                 <a14:useLocalDpi xmlns:a14="http://schemas.microsoft.com/office/drawing/2010/main" val="0"/>
@@ -4246,7 +6075,7 @@
             </p:nvSpPr>
             <p:spPr>
               <a:blipFill>
-                <a:blip r:embed="rId2"/>
+                <a:blip r:embed="rId3"/>
                 <a:stretch>
                   <a:fillRect l="-1043" t="-2241"/>
                 </a:stretch>
@@ -4269,36 +6098,6 @@
       </mc:AlternateContent>
       <p:pic>
         <p:nvPicPr>
-          <p:cNvPr id="4" name="圖片 3">
-            <a:extLst>
-              <a:ext uri="{FF2B5EF4-FFF2-40B4-BE49-F238E27FC236}">
-                <a16:creationId xmlns:a16="http://schemas.microsoft.com/office/drawing/2014/main" id="{011A093A-7BDB-4A77-BF03-6A10620C841E}"/>
-              </a:ext>
-            </a:extLst>
-          </p:cNvPr>
-          <p:cNvPicPr>
-            <a:picLocks noChangeAspect="1"/>
-          </p:cNvPicPr>
-          <p:nvPr/>
-        </p:nvPicPr>
-        <p:blipFill>
-          <a:blip r:embed="rId3"/>
-          <a:stretch>
-            <a:fillRect/>
-          </a:stretch>
-        </p:blipFill>
-        <p:spPr>
-          <a:xfrm>
-            <a:off x="3625702" y="4394167"/>
-            <a:ext cx="5014600" cy="482003"/>
-          </a:xfrm>
-          <a:prstGeom prst="rect">
-            <a:avLst/>
-          </a:prstGeom>
-        </p:spPr>
-      </p:pic>
-      <p:pic>
-        <p:nvPicPr>
           <p:cNvPr id="5" name="圖片 4">
             <a:extLst>
               <a:ext uri="{FF2B5EF4-FFF2-40B4-BE49-F238E27FC236}">
@@ -4321,6 +6120,42 @@
           <a:xfrm>
             <a:off x="3625702" y="3093376"/>
             <a:ext cx="4981026" cy="585489"/>
+          </a:xfrm>
+          <a:prstGeom prst="rect">
+            <a:avLst/>
+          </a:prstGeom>
+        </p:spPr>
+      </p:pic>
+      <p:pic>
+        <p:nvPicPr>
+          <p:cNvPr id="7" name="圖片 6">
+            <a:extLst>
+              <a:ext uri="{FF2B5EF4-FFF2-40B4-BE49-F238E27FC236}">
+                <a16:creationId xmlns:a16="http://schemas.microsoft.com/office/drawing/2014/main" id="{ED2065EF-753D-FC8A-6782-7F12E74717A2}"/>
+              </a:ext>
+            </a:extLst>
+          </p:cNvPr>
+          <p:cNvPicPr>
+            <a:picLocks noChangeAspect="1"/>
+          </p:cNvPicPr>
+          <p:nvPr/>
+        </p:nvPicPr>
+        <p:blipFill>
+          <a:blip r:embed="rId5">
+            <a:extLst>
+              <a:ext uri="{28A0092B-C50C-407E-A947-70E740481C1C}">
+                <a14:useLocalDpi xmlns:a14="http://schemas.microsoft.com/office/drawing/2010/main" val="0"/>
+              </a:ext>
+            </a:extLst>
+          </a:blip>
+          <a:stretch>
+            <a:fillRect/>
+          </a:stretch>
+        </p:blipFill>
+        <p:spPr>
+          <a:xfrm>
+            <a:off x="3517760" y="4184650"/>
+            <a:ext cx="5196909" cy="1090083"/>
           </a:xfrm>
           <a:prstGeom prst="rect">
             <a:avLst/>
@@ -4372,7 +6207,7 @@
           <p:nvPr/>
         </p:nvPicPr>
         <p:blipFill>
-          <a:blip r:embed="rId2"/>
+          <a:blip r:embed="rId3"/>
           <a:stretch>
             <a:fillRect/>
           </a:stretch>
@@ -4461,7 +6296,7 @@
           <p:nvPr/>
         </p:nvPicPr>
         <p:blipFill>
-          <a:blip r:embed="rId3"/>
+          <a:blip r:embed="rId4"/>
           <a:stretch>
             <a:fillRect/>
           </a:stretch>
@@ -4521,7 +6356,7 @@
           <p:nvPr/>
         </p:nvPicPr>
         <p:blipFill>
-          <a:blip r:embed="rId2"/>
+          <a:blip r:embed="rId3"/>
           <a:stretch>
             <a:fillRect/>
           </a:stretch>
@@ -4597,10 +6432,10 @@
       </p:sp>
       <p:pic>
         <p:nvPicPr>
-          <p:cNvPr id="4" name="圖片 3">
-            <a:extLst>
-              <a:ext uri="{FF2B5EF4-FFF2-40B4-BE49-F238E27FC236}">
-                <a16:creationId xmlns:a16="http://schemas.microsoft.com/office/drawing/2014/main" id="{D7110BC4-B4D2-4291-A516-2B736E638A7F}"/>
+          <p:cNvPr id="6" name="圖片 5">
+            <a:extLst>
+              <a:ext uri="{FF2B5EF4-FFF2-40B4-BE49-F238E27FC236}">
+                <a16:creationId xmlns:a16="http://schemas.microsoft.com/office/drawing/2014/main" id="{EDDF61E7-B017-A99C-48B2-A828930016B1}"/>
               </a:ext>
             </a:extLst>
           </p:cNvPr>
@@ -4610,15 +6445,21 @@
           <p:nvPr/>
         </p:nvPicPr>
         <p:blipFill>
-          <a:blip r:embed="rId3"/>
+          <a:blip r:embed="rId4">
+            <a:extLst>
+              <a:ext uri="{28A0092B-C50C-407E-A947-70E740481C1C}">
+                <a14:useLocalDpi xmlns:a14="http://schemas.microsoft.com/office/drawing/2010/main" val="0"/>
+              </a:ext>
+            </a:extLst>
+          </a:blip>
           <a:stretch>
             <a:fillRect/>
           </a:stretch>
         </p:blipFill>
         <p:spPr>
           <a:xfrm>
-            <a:off x="2147352" y="3187998"/>
-            <a:ext cx="5014600" cy="482003"/>
+            <a:off x="2110277" y="2951552"/>
+            <a:ext cx="4522343" cy="948589"/>
           </a:xfrm>
           <a:prstGeom prst="rect">
             <a:avLst/>
@@ -5689,7 +7530,7 @@
           <p:nvPr/>
         </p:nvPicPr>
         <p:blipFill>
-          <a:blip r:embed="rId2"/>
+          <a:blip r:embed="rId3"/>
           <a:stretch>
             <a:fillRect/>
           </a:stretch>
@@ -5785,7 +7626,7 @@
           <a:bodyPr/>
           <a:lstStyle/>
           <a:p>
-            <a:endParaRPr lang="zh-TW" altLang="en-US"/>
+            <a:endParaRPr lang="zh-TW" altLang="en-US" dirty="0"/>
           </a:p>
         </p:txBody>
       </p:sp>
@@ -6577,7 +8418,7 @@
             </a:r>
             <a:r>
               <a:rPr lang="en-US" altLang="zh-TW" b="1" dirty="0"/>
-              <a:t>2025-09-24 (Wed) 23:59</a:t>
+              <a:t>2026-09-30 (Wed) 23:59</a:t>
             </a:r>
             <a:endParaRPr lang="zh-TW" altLang="en-US" b="1" dirty="0"/>
           </a:p>
@@ -7423,7 +9264,7 @@
           <p:nvPr/>
         </p:nvPicPr>
         <p:blipFill>
-          <a:blip r:embed="rId2">
+          <a:blip r:embed="rId3">
             <a:extLst>
               <a:ext uri="{28A0092B-C50C-407E-A947-70E740481C1C}">
                 <a14:useLocalDpi xmlns:a14="http://schemas.microsoft.com/office/drawing/2010/main" val="0"/>
@@ -7459,7 +9300,7 @@
           <p:nvPr/>
         </p:nvPicPr>
         <p:blipFill>
-          <a:blip r:embed="rId3">
+          <a:blip r:embed="rId4">
             <a:extLst>
               <a:ext uri="{28A0092B-C50C-407E-A947-70E740481C1C}">
                 <a14:useLocalDpi xmlns:a14="http://schemas.microsoft.com/office/drawing/2010/main" val="0"/>
@@ -7495,7 +9336,7 @@
           <p:nvPr/>
         </p:nvPicPr>
         <p:blipFill>
-          <a:blip r:embed="rId4">
+          <a:blip r:embed="rId5">
             <a:extLst>
               <a:ext uri="{28A0092B-C50C-407E-A947-70E740481C1C}">
                 <a14:useLocalDpi xmlns:a14="http://schemas.microsoft.com/office/drawing/2010/main" val="0"/>
@@ -7626,7 +9467,7 @@
           <p:nvPr/>
         </p:nvPicPr>
         <p:blipFill>
-          <a:blip r:embed="rId2">
+          <a:blip r:embed="rId3">
             <a:extLst>
               <a:ext uri="{28A0092B-C50C-407E-A947-70E740481C1C}">
                 <a14:useLocalDpi xmlns:a14="http://schemas.microsoft.com/office/drawing/2010/main" val="0"/>
@@ -7662,7 +9503,7 @@
           <p:nvPr/>
         </p:nvPicPr>
         <p:blipFill rotWithShape="1">
-          <a:blip r:embed="rId3"/>
+          <a:blip r:embed="rId4"/>
           <a:srcRect l="1383" t="10187" r="63222"/>
           <a:stretch/>
         </p:blipFill>
@@ -8161,4 +10002,319 @@
     </a:ext>
   </a:extLst>
 </a:theme>
+</file>
+
+<file path=ppt/theme/theme2.xml><?xml version="1.0" encoding="utf-8"?>
+<a:theme xmlns:a="http://schemas.openxmlformats.org/drawingml/2006/main" name="Office 佈景主題">
+  <a:themeElements>
+    <a:clrScheme name="Office">
+      <a:dk1>
+        <a:sysClr val="windowText" lastClr="000000"/>
+      </a:dk1>
+      <a:lt1>
+        <a:sysClr val="window" lastClr="FFFFFF"/>
+      </a:lt1>
+      <a:dk2>
+        <a:srgbClr val="0E2841"/>
+      </a:dk2>
+      <a:lt2>
+        <a:srgbClr val="E8E8E8"/>
+      </a:lt2>
+      <a:accent1>
+        <a:srgbClr val="156082"/>
+      </a:accent1>
+      <a:accent2>
+        <a:srgbClr val="E97132"/>
+      </a:accent2>
+      <a:accent3>
+        <a:srgbClr val="196B24"/>
+      </a:accent3>
+      <a:accent4>
+        <a:srgbClr val="0F9ED5"/>
+      </a:accent4>
+      <a:accent5>
+        <a:srgbClr val="A02B93"/>
+      </a:accent5>
+      <a:accent6>
+        <a:srgbClr val="4EA72E"/>
+      </a:accent6>
+      <a:hlink>
+        <a:srgbClr val="467886"/>
+      </a:hlink>
+      <a:folHlink>
+        <a:srgbClr val="96607D"/>
+      </a:folHlink>
+    </a:clrScheme>
+    <a:fontScheme name="Office">
+      <a:majorFont>
+        <a:latin typeface="Aptos Display" panose="02110004020202020204"/>
+        <a:ea typeface=""/>
+        <a:cs typeface=""/>
+        <a:font script="Jpan" typeface="游ゴシック Light"/>
+        <a:font script="Hang" typeface="맑은 고딕"/>
+        <a:font script="Hans" typeface="等线 Light"/>
+        <a:font script="Hant" typeface="新細明體"/>
+        <a:font script="Arab" typeface="Times New Roman"/>
+        <a:font script="Hebr" typeface="Times New Roman"/>
+        <a:font script="Thai" typeface="Angsana New"/>
+        <a:font script="Ethi" typeface="Nyala"/>
+        <a:font script="Beng" typeface="Vrinda"/>
+        <a:font script="Gujr" typeface="Shruti"/>
+        <a:font script="Khmr" typeface="MoolBoran"/>
+        <a:font script="Knda" typeface="Tunga"/>
+        <a:font script="Guru" typeface="Raavi"/>
+        <a:font script="Cans" typeface="Euphemia"/>
+        <a:font script="Cher" typeface="Plantagenet Cherokee"/>
+        <a:font script="Yiii" typeface="Microsoft Yi Baiti"/>
+        <a:font script="Tibt" typeface="Microsoft Himalaya"/>
+        <a:font script="Thaa" typeface="MV Boli"/>
+        <a:font script="Deva" typeface="Mangal"/>
+        <a:font script="Telu" typeface="Gautami"/>
+        <a:font script="Taml" typeface="Latha"/>
+        <a:font script="Syrc" typeface="Estrangelo Edessa"/>
+        <a:font script="Orya" typeface="Kalinga"/>
+        <a:font script="Mlym" typeface="Kartika"/>
+        <a:font script="Laoo" typeface="DokChampa"/>
+        <a:font script="Sinh" typeface="Iskoola Pota"/>
+        <a:font script="Mong" typeface="Mongolian Baiti"/>
+        <a:font script="Viet" typeface="Times New Roman"/>
+        <a:font script="Uigh" typeface="Microsoft Uighur"/>
+        <a:font script="Geor" typeface="Sylfaen"/>
+        <a:font script="Armn" typeface="Arial"/>
+        <a:font script="Bugi" typeface="Leelawadee UI"/>
+        <a:font script="Bopo" typeface="Microsoft JhengHei"/>
+        <a:font script="Java" typeface="Javanese Text"/>
+        <a:font script="Lisu" typeface="Segoe UI"/>
+        <a:font script="Mymr" typeface="Myanmar Text"/>
+        <a:font script="Nkoo" typeface="Ebrima"/>
+        <a:font script="Olck" typeface="Nirmala UI"/>
+        <a:font script="Osma" typeface="Ebrima"/>
+        <a:font script="Phag" typeface="Phagspa"/>
+        <a:font script="Syrn" typeface="Estrangelo Edessa"/>
+        <a:font script="Syrj" typeface="Estrangelo Edessa"/>
+        <a:font script="Syre" typeface="Estrangelo Edessa"/>
+        <a:font script="Sora" typeface="Nirmala UI"/>
+        <a:font script="Tale" typeface="Microsoft Tai Le"/>
+        <a:font script="Talu" typeface="Microsoft New Tai Lue"/>
+        <a:font script="Tfng" typeface="Ebrima"/>
+      </a:majorFont>
+      <a:minorFont>
+        <a:latin typeface="Aptos" panose="02110004020202020204"/>
+        <a:ea typeface=""/>
+        <a:cs typeface=""/>
+        <a:font script="Jpan" typeface="游ゴシック"/>
+        <a:font script="Hang" typeface="맑은 고딕"/>
+        <a:font script="Hans" typeface="等线"/>
+        <a:font script="Hant" typeface="新細明體"/>
+        <a:font script="Arab" typeface="Arial"/>
+        <a:font script="Hebr" typeface="Arial"/>
+        <a:font script="Thai" typeface="Cordia New"/>
+        <a:font script="Ethi" typeface="Nyala"/>
+        <a:font script="Beng" typeface="Vrinda"/>
+        <a:font script="Gujr" typeface="Shruti"/>
+        <a:font script="Khmr" typeface="DaunPenh"/>
+        <a:font script="Knda" typeface="Tunga"/>
+        <a:font script="Guru" typeface="Raavi"/>
+        <a:font script="Cans" typeface="Euphemia"/>
+        <a:font script="Cher" typeface="Plantagenet Cherokee"/>
+        <a:font script="Yiii" typeface="Microsoft Yi Baiti"/>
+        <a:font script="Tibt" typeface="Microsoft Himalaya"/>
+        <a:font script="Thaa" typeface="MV Boli"/>
+        <a:font script="Deva" typeface="Mangal"/>
+        <a:font script="Telu" typeface="Gautami"/>
+        <a:font script="Taml" typeface="Latha"/>
+        <a:font script="Syrc" typeface="Estrangelo Edessa"/>
+        <a:font script="Orya" typeface="Kalinga"/>
+        <a:font script="Mlym" typeface="Kartika"/>
+        <a:font script="Laoo" typeface="DokChampa"/>
+        <a:font script="Sinh" typeface="Iskoola Pota"/>
+        <a:font script="Mong" typeface="Mongolian Baiti"/>
+        <a:font script="Viet" typeface="Arial"/>
+        <a:font script="Uigh" typeface="Microsoft Uighur"/>
+        <a:font script="Geor" typeface="Sylfaen"/>
+        <a:font script="Armn" typeface="Arial"/>
+        <a:font script="Bugi" typeface="Leelawadee UI"/>
+        <a:font script="Bopo" typeface="Microsoft JhengHei"/>
+        <a:font script="Java" typeface="Javanese Text"/>
+        <a:font script="Lisu" typeface="Segoe UI"/>
+        <a:font script="Mymr" typeface="Myanmar Text"/>
+        <a:font script="Nkoo" typeface="Ebrima"/>
+        <a:font script="Olck" typeface="Nirmala UI"/>
+        <a:font script="Osma" typeface="Ebrima"/>
+        <a:font script="Phag" typeface="Phagspa"/>
+        <a:font script="Syrn" typeface="Estrangelo Edessa"/>
+        <a:font script="Syrj" typeface="Estrangelo Edessa"/>
+        <a:font script="Syre" typeface="Estrangelo Edessa"/>
+        <a:font script="Sora" typeface="Nirmala UI"/>
+        <a:font script="Tale" typeface="Microsoft Tai Le"/>
+        <a:font script="Talu" typeface="Microsoft New Tai Lue"/>
+        <a:font script="Tfng" typeface="Ebrima"/>
+      </a:minorFont>
+    </a:fontScheme>
+    <a:fmtScheme name="Office">
+      <a:fillStyleLst>
+        <a:solidFill>
+          <a:schemeClr val="phClr"/>
+        </a:solidFill>
+        <a:gradFill rotWithShape="1">
+          <a:gsLst>
+            <a:gs pos="0">
+              <a:schemeClr val="phClr">
+                <a:lumMod val="110000"/>
+                <a:satMod val="105000"/>
+                <a:tint val="67000"/>
+              </a:schemeClr>
+            </a:gs>
+            <a:gs pos="50000">
+              <a:schemeClr val="phClr">
+                <a:lumMod val="105000"/>
+                <a:satMod val="103000"/>
+                <a:tint val="73000"/>
+              </a:schemeClr>
+            </a:gs>
+            <a:gs pos="100000">
+              <a:schemeClr val="phClr">
+                <a:lumMod val="105000"/>
+                <a:satMod val="109000"/>
+                <a:tint val="81000"/>
+              </a:schemeClr>
+            </a:gs>
+          </a:gsLst>
+          <a:lin ang="5400000" scaled="0"/>
+        </a:gradFill>
+        <a:gradFill rotWithShape="1">
+          <a:gsLst>
+            <a:gs pos="0">
+              <a:schemeClr val="phClr">
+                <a:satMod val="103000"/>
+                <a:lumMod val="102000"/>
+                <a:tint val="94000"/>
+              </a:schemeClr>
+            </a:gs>
+            <a:gs pos="50000">
+              <a:schemeClr val="phClr">
+                <a:satMod val="110000"/>
+                <a:lumMod val="100000"/>
+                <a:shade val="100000"/>
+              </a:schemeClr>
+            </a:gs>
+            <a:gs pos="100000">
+              <a:schemeClr val="phClr">
+                <a:lumMod val="99000"/>
+                <a:satMod val="120000"/>
+                <a:shade val="78000"/>
+              </a:schemeClr>
+            </a:gs>
+          </a:gsLst>
+          <a:lin ang="5400000" scaled="0"/>
+        </a:gradFill>
+      </a:fillStyleLst>
+      <a:lnStyleLst>
+        <a:ln w="12700" cap="flat" cmpd="sng" algn="ctr">
+          <a:solidFill>
+            <a:schemeClr val="phClr"/>
+          </a:solidFill>
+          <a:prstDash val="solid"/>
+          <a:miter lim="800000"/>
+        </a:ln>
+        <a:ln w="19050" cap="flat" cmpd="sng" algn="ctr">
+          <a:solidFill>
+            <a:schemeClr val="phClr"/>
+          </a:solidFill>
+          <a:prstDash val="solid"/>
+          <a:miter lim="800000"/>
+        </a:ln>
+        <a:ln w="25400" cap="flat" cmpd="sng" algn="ctr">
+          <a:solidFill>
+            <a:schemeClr val="phClr"/>
+          </a:solidFill>
+          <a:prstDash val="solid"/>
+          <a:miter lim="800000"/>
+        </a:ln>
+      </a:lnStyleLst>
+      <a:effectStyleLst>
+        <a:effectStyle>
+          <a:effectLst/>
+        </a:effectStyle>
+        <a:effectStyle>
+          <a:effectLst/>
+        </a:effectStyle>
+        <a:effectStyle>
+          <a:effectLst>
+            <a:outerShdw blurRad="57150" dist="19050" dir="5400000" algn="ctr" rotWithShape="0">
+              <a:srgbClr val="000000">
+                <a:alpha val="63000"/>
+              </a:srgbClr>
+            </a:outerShdw>
+          </a:effectLst>
+        </a:effectStyle>
+      </a:effectStyleLst>
+      <a:bgFillStyleLst>
+        <a:solidFill>
+          <a:schemeClr val="phClr"/>
+        </a:solidFill>
+        <a:solidFill>
+          <a:schemeClr val="phClr">
+            <a:tint val="95000"/>
+            <a:satMod val="170000"/>
+          </a:schemeClr>
+        </a:solidFill>
+        <a:gradFill rotWithShape="1">
+          <a:gsLst>
+            <a:gs pos="0">
+              <a:schemeClr val="phClr">
+                <a:tint val="93000"/>
+                <a:satMod val="150000"/>
+                <a:shade val="98000"/>
+                <a:lumMod val="102000"/>
+              </a:schemeClr>
+            </a:gs>
+            <a:gs pos="50000">
+              <a:schemeClr val="phClr">
+                <a:tint val="98000"/>
+                <a:satMod val="130000"/>
+                <a:shade val="90000"/>
+                <a:lumMod val="103000"/>
+              </a:schemeClr>
+            </a:gs>
+            <a:gs pos="100000">
+              <a:schemeClr val="phClr">
+                <a:shade val="63000"/>
+                <a:satMod val="120000"/>
+              </a:schemeClr>
+            </a:gs>
+          </a:gsLst>
+          <a:lin ang="5400000" scaled="0"/>
+        </a:gradFill>
+      </a:bgFillStyleLst>
+    </a:fmtScheme>
+  </a:themeElements>
+  <a:objectDefaults>
+    <a:lnDef>
+      <a:spPr/>
+      <a:bodyPr/>
+      <a:lstStyle/>
+      <a:style>
+        <a:lnRef idx="2">
+          <a:schemeClr val="accent1"/>
+        </a:lnRef>
+        <a:fillRef idx="0">
+          <a:schemeClr val="accent1"/>
+        </a:fillRef>
+        <a:effectRef idx="1">
+          <a:schemeClr val="accent1"/>
+        </a:effectRef>
+        <a:fontRef idx="minor">
+          <a:schemeClr val="tx1"/>
+        </a:fontRef>
+      </a:style>
+    </a:lnDef>
+  </a:objectDefaults>
+  <a:extraClrSchemeLst/>
+  <a:extLst>
+    <a:ext uri="{05A4C25C-085E-4340-85A3-A5531E510DB2}">
+      <thm15:themeFamily xmlns:thm15="http://schemas.microsoft.com/office/thememl/2012/main" name="Office Theme" id="{2E142A2C-CD16-42D6-873A-C26D2A0506FA}" vid="{1BDDFF52-6CD6-40A5-AB3C-68EB2F1E4D0A}"/>
+    </a:ext>
+  </a:extLst>
+</a:theme>
 </file>
</xml_diff>